<commit_message>
Deploying to gh-pages from @ tamanh-oxford/capacity-development@c1cb87dd08250a43505eda63e980259f09cdb7f8 🚀
</commit_message>
<xml_diff>
--- a/data-frameworks/01-global-landscape.pptx
+++ b/data-frameworks/01-global-landscape.pptx
@@ -4,8 +4,36 @@
   <p:sldMasterIdLst>
     <p:sldMasterId id="2147483648" r:id="rId1"/>
   </p:sldMasterIdLst>
+  <p:notesMasterIdLst>
+    <p:notesMasterId r:id="rId28"/>
+  </p:notesMasterIdLst>
   <p:sldIdLst>
     <p:sldId id="256" r:id="rId2"/>
+    <p:sldId id="257" r:id="rId3"/>
+    <p:sldId id="258" r:id="rId4"/>
+    <p:sldId id="259" r:id="rId5"/>
+    <p:sldId id="260" r:id="rId6"/>
+    <p:sldId id="261" r:id="rId7"/>
+    <p:sldId id="262" r:id="rId8"/>
+    <p:sldId id="263" r:id="rId9"/>
+    <p:sldId id="264" r:id="rId10"/>
+    <p:sldId id="265" r:id="rId11"/>
+    <p:sldId id="266" r:id="rId12"/>
+    <p:sldId id="267" r:id="rId13"/>
+    <p:sldId id="268" r:id="rId14"/>
+    <p:sldId id="269" r:id="rId15"/>
+    <p:sldId id="270" r:id="rId16"/>
+    <p:sldId id="271" r:id="rId17"/>
+    <p:sldId id="272" r:id="rId18"/>
+    <p:sldId id="273" r:id="rId19"/>
+    <p:sldId id="274" r:id="rId20"/>
+    <p:sldId id="275" r:id="rId21"/>
+    <p:sldId id="276" r:id="rId22"/>
+    <p:sldId id="277" r:id="rId23"/>
+    <p:sldId id="278" r:id="rId24"/>
+    <p:sldId id="279" r:id="rId25"/>
+    <p:sldId id="280" r:id="rId26"/>
+    <p:sldId id="281" r:id="rId27"/>
   </p:sldIdLst>
   <p:sldSz cx="9144000" cy="5143500" type="screen16x9"/>
   <p:notesSz cx="6858000" cy="9144000"/>
@@ -121,6 +149,483 @@
     </p:ext>
   </p:extLst>
 </p:presentation>
+</file>
+
+<file path=ppt/notesMasters/notesMaster1.xml><?xml version="1.0" encoding="utf-8"?>
+<p:notesMaster xmlns:a="http://schemas.openxmlformats.org/drawingml/2006/main" xmlns:r="http://schemas.openxmlformats.org/officeDocument/2006/relationships" xmlns:p="http://schemas.openxmlformats.org/presentationml/2006/main">
+  <p:cSld>
+    <p:bg>
+      <p:bgRef idx="1001">
+        <a:schemeClr val="bg1"/>
+      </p:bgRef>
+    </p:bg>
+    <p:spTree>
+      <p:nvGrpSpPr>
+        <p:cNvPr id="1" name=""/>
+        <p:cNvGrpSpPr/>
+        <p:nvPr/>
+      </p:nvGrpSpPr>
+      <p:grpSpPr>
+        <a:xfrm>
+          <a:off x="0" y="0"/>
+          <a:ext cx="0" cy="0"/>
+          <a:chOff x="0" y="0"/>
+          <a:chExt cx="0" cy="0"/>
+        </a:xfrm>
+      </p:grpSpPr>
+      <p:sp>
+        <p:nvSpPr>
+          <p:cNvPr id="2" name="Header Placeholder 1"/>
+          <p:cNvSpPr>
+            <a:spLocks noGrp="1"/>
+          </p:cNvSpPr>
+          <p:nvPr>
+            <p:ph type="hdr" sz="quarter"/>
+          </p:nvPr>
+        </p:nvSpPr>
+        <p:spPr>
+          <a:xfrm>
+            <a:off x="0" y="0"/>
+            <a:ext cx="2971800" cy="458788"/>
+          </a:xfrm>
+          <a:prstGeom prst="rect">
+            <a:avLst/>
+          </a:prstGeom>
+        </p:spPr>
+        <p:txBody>
+          <a:bodyPr vert="horz" lIns="91440" tIns="45720" rIns="91440" bIns="45720" rtlCol="0"/>
+          <a:lstStyle>
+            <a:lvl1pPr algn="l">
+              <a:defRPr sz="1200"/>
+            </a:lvl1pPr>
+          </a:lstStyle>
+          <a:p>
+            <a:endParaRPr lang="en-US"/>
+          </a:p>
+        </p:txBody>
+      </p:sp>
+      <p:sp>
+        <p:nvSpPr>
+          <p:cNvPr id="3" name="Date Placeholder 2"/>
+          <p:cNvSpPr>
+            <a:spLocks noGrp="1"/>
+          </p:cNvSpPr>
+          <p:nvPr>
+            <p:ph type="dt" idx="1"/>
+          </p:nvPr>
+        </p:nvSpPr>
+        <p:spPr>
+          <a:xfrm>
+            <a:off x="3884613" y="0"/>
+            <a:ext cx="2971800" cy="458788"/>
+          </a:xfrm>
+          <a:prstGeom prst="rect">
+            <a:avLst/>
+          </a:prstGeom>
+        </p:spPr>
+        <p:txBody>
+          <a:bodyPr vert="horz" lIns="91440" tIns="45720" rIns="91440" bIns="45720" rtlCol="0"/>
+          <a:lstStyle>
+            <a:lvl1pPr algn="r">
+              <a:defRPr sz="1200"/>
+            </a:lvl1pPr>
+          </a:lstStyle>
+          <a:p>
+            <a:fld id="{0F9C1CCF-B725-44A7-AA57-5E433BD85C9F}" type="datetimeFigureOut">
+              <a:rPr lang="en-US" smtClean="0"/>
+              <a:t>1/2/22</a:t>
+            </a:fld>
+            <a:endParaRPr lang="en-US"/>
+          </a:p>
+        </p:txBody>
+      </p:sp>
+      <p:sp>
+        <p:nvSpPr>
+          <p:cNvPr id="4" name="Slide Image Placeholder 3"/>
+          <p:cNvSpPr>
+            <a:spLocks noGrp="1" noRot="1" noChangeAspect="1"/>
+          </p:cNvSpPr>
+          <p:nvPr>
+            <p:ph type="sldImg" idx="2"/>
+          </p:nvPr>
+        </p:nvSpPr>
+        <p:spPr>
+          <a:xfrm>
+            <a:off x="685800" y="1143000"/>
+            <a:ext cx="5486400" cy="3086100"/>
+          </a:xfrm>
+          <a:prstGeom prst="rect">
+            <a:avLst/>
+          </a:prstGeom>
+          <a:noFill/>
+          <a:ln w="12700">
+            <a:solidFill>
+              <a:prstClr val="black"/>
+            </a:solidFill>
+          </a:ln>
+        </p:spPr>
+        <p:txBody>
+          <a:bodyPr vert="horz" lIns="91440" tIns="45720" rIns="91440" bIns="45720" rtlCol="0" anchor="ctr"/>
+          <a:lstStyle/>
+          <a:p>
+            <a:endParaRPr lang="en-US"/>
+          </a:p>
+        </p:txBody>
+      </p:sp>
+      <p:sp>
+        <p:nvSpPr>
+          <p:cNvPr id="5" name="Notes Placeholder 4"/>
+          <p:cNvSpPr>
+            <a:spLocks noGrp="1"/>
+          </p:cNvSpPr>
+          <p:nvPr>
+            <p:ph type="body" sz="quarter" idx="3"/>
+          </p:nvPr>
+        </p:nvSpPr>
+        <p:spPr>
+          <a:xfrm>
+            <a:off x="685800" y="4400550"/>
+            <a:ext cx="5486400" cy="3600450"/>
+          </a:xfrm>
+          <a:prstGeom prst="rect">
+            <a:avLst/>
+          </a:prstGeom>
+        </p:spPr>
+        <p:txBody>
+          <a:bodyPr vert="horz" lIns="91440" tIns="45720" rIns="91440" bIns="45720" rtlCol="0"/>
+          <a:lstStyle/>
+          <a:p>
+            <a:pPr lvl="0"/>
+            <a:r>
+              <a:rPr lang="en-US"/>
+              <a:t>Click to edit Master text styles</a:t>
+            </a:r>
+          </a:p>
+          <a:p>
+            <a:pPr lvl="1"/>
+            <a:r>
+              <a:rPr lang="en-US"/>
+              <a:t>Second level</a:t>
+            </a:r>
+          </a:p>
+          <a:p>
+            <a:pPr lvl="2"/>
+            <a:r>
+              <a:rPr lang="en-US"/>
+              <a:t>Third level</a:t>
+            </a:r>
+          </a:p>
+          <a:p>
+            <a:pPr lvl="3"/>
+            <a:r>
+              <a:rPr lang="en-US"/>
+              <a:t>Fourth level</a:t>
+            </a:r>
+          </a:p>
+          <a:p>
+            <a:pPr lvl="4"/>
+            <a:r>
+              <a:rPr lang="en-US"/>
+              <a:t>Fifth level</a:t>
+            </a:r>
+          </a:p>
+        </p:txBody>
+      </p:sp>
+      <p:sp>
+        <p:nvSpPr>
+          <p:cNvPr id="6" name="Footer Placeholder 5"/>
+          <p:cNvSpPr>
+            <a:spLocks noGrp="1"/>
+          </p:cNvSpPr>
+          <p:nvPr>
+            <p:ph type="ftr" sz="quarter" idx="4"/>
+          </p:nvPr>
+        </p:nvSpPr>
+        <p:spPr>
+          <a:xfrm>
+            <a:off x="0" y="8685213"/>
+            <a:ext cx="2971800" cy="458787"/>
+          </a:xfrm>
+          <a:prstGeom prst="rect">
+            <a:avLst/>
+          </a:prstGeom>
+        </p:spPr>
+        <p:txBody>
+          <a:bodyPr vert="horz" lIns="91440" tIns="45720" rIns="91440" bIns="45720" rtlCol="0" anchor="b"/>
+          <a:lstStyle>
+            <a:lvl1pPr algn="l">
+              <a:defRPr sz="1200"/>
+            </a:lvl1pPr>
+          </a:lstStyle>
+          <a:p>
+            <a:endParaRPr lang="en-US"/>
+          </a:p>
+        </p:txBody>
+      </p:sp>
+      <p:sp>
+        <p:nvSpPr>
+          <p:cNvPr id="7" name="Slide Number Placeholder 6"/>
+          <p:cNvSpPr>
+            <a:spLocks noGrp="1"/>
+          </p:cNvSpPr>
+          <p:nvPr>
+            <p:ph type="sldNum" sz="quarter" idx="5"/>
+          </p:nvPr>
+        </p:nvSpPr>
+        <p:spPr>
+          <a:xfrm>
+            <a:off x="3884613" y="8685213"/>
+            <a:ext cx="2971800" cy="458787"/>
+          </a:xfrm>
+          <a:prstGeom prst="rect">
+            <a:avLst/>
+          </a:prstGeom>
+        </p:spPr>
+        <p:txBody>
+          <a:bodyPr vert="horz" lIns="91440" tIns="45720" rIns="91440" bIns="45720" rtlCol="0" anchor="b"/>
+          <a:lstStyle>
+            <a:lvl1pPr algn="r">
+              <a:defRPr sz="1200"/>
+            </a:lvl1pPr>
+          </a:lstStyle>
+          <a:p>
+            <a:fld id="{18BDFEC3-8487-43E8-A154-7C12CBC1FFF2}" type="slidenum">
+              <a:rPr lang="en-US" smtClean="0"/>
+              <a:t>‹#›</a:t>
+            </a:fld>
+            <a:endParaRPr lang="en-US"/>
+          </a:p>
+        </p:txBody>
+      </p:sp>
+    </p:spTree>
+    <p:extLst>
+      <p:ext uri="{BB962C8B-B14F-4D97-AF65-F5344CB8AC3E}">
+        <p14:creationId xmlns:p14="http://schemas.microsoft.com/office/powerpoint/2010/main" val="3782709779"/>
+      </p:ext>
+    </p:extLst>
+  </p:cSld>
+  <p:clrMap bg1="lt1" tx1="dk1" bg2="lt2" tx2="dk2" accent1="accent1" accent2="accent2" accent3="accent3" accent4="accent4" accent5="accent5" accent6="accent6" hlink="hlink" folHlink="folHlink"/>
+  <p:notesStyle>
+    <a:lvl1pPr marL="0" algn="l" defTabSz="914400" rtl="0" eaLnBrk="1" latinLnBrk="0" hangingPunct="1">
+      <a:defRPr sz="1200" kern="1200">
+        <a:solidFill>
+          <a:schemeClr val="tx1"/>
+        </a:solidFill>
+        <a:latin typeface="+mn-lt"/>
+        <a:ea typeface="+mn-ea"/>
+        <a:cs typeface="+mn-cs"/>
+      </a:defRPr>
+    </a:lvl1pPr>
+    <a:lvl2pPr marL="457200" algn="l" defTabSz="914400" rtl="0" eaLnBrk="1" latinLnBrk="0" hangingPunct="1">
+      <a:defRPr sz="1200" kern="1200">
+        <a:solidFill>
+          <a:schemeClr val="tx1"/>
+        </a:solidFill>
+        <a:latin typeface="+mn-lt"/>
+        <a:ea typeface="+mn-ea"/>
+        <a:cs typeface="+mn-cs"/>
+      </a:defRPr>
+    </a:lvl2pPr>
+    <a:lvl3pPr marL="914400" algn="l" defTabSz="914400" rtl="0" eaLnBrk="1" latinLnBrk="0" hangingPunct="1">
+      <a:defRPr sz="1200" kern="1200">
+        <a:solidFill>
+          <a:schemeClr val="tx1"/>
+        </a:solidFill>
+        <a:latin typeface="+mn-lt"/>
+        <a:ea typeface="+mn-ea"/>
+        <a:cs typeface="+mn-cs"/>
+      </a:defRPr>
+    </a:lvl3pPr>
+    <a:lvl4pPr marL="1371600" algn="l" defTabSz="914400" rtl="0" eaLnBrk="1" latinLnBrk="0" hangingPunct="1">
+      <a:defRPr sz="1200" kern="1200">
+        <a:solidFill>
+          <a:schemeClr val="tx1"/>
+        </a:solidFill>
+        <a:latin typeface="+mn-lt"/>
+        <a:ea typeface="+mn-ea"/>
+        <a:cs typeface="+mn-cs"/>
+      </a:defRPr>
+    </a:lvl4pPr>
+    <a:lvl5pPr marL="1828800" algn="l" defTabSz="914400" rtl="0" eaLnBrk="1" latinLnBrk="0" hangingPunct="1">
+      <a:defRPr sz="1200" kern="1200">
+        <a:solidFill>
+          <a:schemeClr val="tx1"/>
+        </a:solidFill>
+        <a:latin typeface="+mn-lt"/>
+        <a:ea typeface="+mn-ea"/>
+        <a:cs typeface="+mn-cs"/>
+      </a:defRPr>
+    </a:lvl5pPr>
+    <a:lvl6pPr marL="2286000" algn="l" defTabSz="914400" rtl="0" eaLnBrk="1" latinLnBrk="0" hangingPunct="1">
+      <a:defRPr sz="1200" kern="1200">
+        <a:solidFill>
+          <a:schemeClr val="tx1"/>
+        </a:solidFill>
+        <a:latin typeface="+mn-lt"/>
+        <a:ea typeface="+mn-ea"/>
+        <a:cs typeface="+mn-cs"/>
+      </a:defRPr>
+    </a:lvl6pPr>
+    <a:lvl7pPr marL="2743200" algn="l" defTabSz="914400" rtl="0" eaLnBrk="1" latinLnBrk="0" hangingPunct="1">
+      <a:defRPr sz="1200" kern="1200">
+        <a:solidFill>
+          <a:schemeClr val="tx1"/>
+        </a:solidFill>
+        <a:latin typeface="+mn-lt"/>
+        <a:ea typeface="+mn-ea"/>
+        <a:cs typeface="+mn-cs"/>
+      </a:defRPr>
+    </a:lvl7pPr>
+    <a:lvl8pPr marL="3200400" algn="l" defTabSz="914400" rtl="0" eaLnBrk="1" latinLnBrk="0" hangingPunct="1">
+      <a:defRPr sz="1200" kern="1200">
+        <a:solidFill>
+          <a:schemeClr val="tx1"/>
+        </a:solidFill>
+        <a:latin typeface="+mn-lt"/>
+        <a:ea typeface="+mn-ea"/>
+        <a:cs typeface="+mn-cs"/>
+      </a:defRPr>
+    </a:lvl8pPr>
+    <a:lvl9pPr marL="3657600" algn="l" defTabSz="914400" rtl="0" eaLnBrk="1" latinLnBrk="0" hangingPunct="1">
+      <a:defRPr sz="1200" kern="1200">
+        <a:solidFill>
+          <a:schemeClr val="tx1"/>
+        </a:solidFill>
+        <a:latin typeface="+mn-lt"/>
+        <a:ea typeface="+mn-ea"/>
+        <a:cs typeface="+mn-cs"/>
+      </a:defRPr>
+    </a:lvl9pPr>
+  </p:notesStyle>
+</p:notesMaster>
+</file>
+
+<file path=ppt/notesSlides/notesSlide1.xml><?xml version="1.0" encoding="utf-8"?>
+<p:notes xmlns:a="http://schemas.openxmlformats.org/drawingml/2006/main" xmlns:r="http://schemas.openxmlformats.org/officeDocument/2006/relationships" xmlns:p="http://schemas.openxmlformats.org/presentationml/2006/main">
+  <p:cSld>
+    <p:spTree>
+      <p:nvGrpSpPr>
+        <p:cNvPr id="1" name=""/>
+        <p:cNvGrpSpPr/>
+        <p:nvPr/>
+      </p:nvGrpSpPr>
+      <p:grpSpPr>
+        <a:xfrm>
+          <a:off x="0" y="0"/>
+          <a:ext cx="0" cy="0"/>
+          <a:chOff x="0" y="0"/>
+          <a:chExt cx="0" cy="0"/>
+        </a:xfrm>
+      </p:grpSpPr>
+      <p:sp>
+        <p:nvSpPr>
+          <p:cNvPr id="2" name="Slide Image Placeholder 1"/>
+          <p:cNvSpPr>
+            <a:spLocks noGrp="1" noRot="1" noChangeAspect="1"/>
+          </p:cNvSpPr>
+          <p:nvPr>
+            <p:ph type="sldImg"/>
+          </p:nvPr>
+        </p:nvSpPr>
+        <p:spPr/>
+      </p:sp>
+      <p:sp>
+        <p:nvSpPr>
+          <p:cNvPr id="3" name="Notes Placeholder 2"/>
+          <p:cNvSpPr>
+            <a:spLocks noGrp="1"/>
+          </p:cNvSpPr>
+          <p:nvPr>
+            <p:ph type="body" idx="1"/>
+          </p:nvPr>
+        </p:nvSpPr>
+        <p:spPr/>
+        <p:txBody>
+          <a:bodyPr/>
+          <a:lstStyle/>
+          <a:p>
+            <a:pPr lvl="0"/>
+            <a:r>
+              <a:rPr/>
+              <a:t>Data not immune to influence from stakeholders</a:t>
+            </a:r>
+          </a:p>
+          <a:p>
+            <a:pPr lvl="0" indent="0" marL="0">
+              <a:buNone/>
+            </a:pPr>
+          </a:p>
+          <a:p>
+            <a:pPr lvl="1"/>
+            <a:r>
+              <a:rPr/>
+              <a:t>Example: Greece’s debt statistics appear to have deliberately misrepresented the country’s financial situation in the lead-up to the 2009 euro crisis</a:t>
+            </a:r>
+          </a:p>
+          <a:p>
+            <a:pPr lvl="0" indent="0" marL="0">
+              <a:buNone/>
+            </a:pPr>
+          </a:p>
+          <a:p>
+            <a:pPr lvl="0"/>
+            <a:r>
+              <a:rPr/>
+              <a:t>Data not stored securely - too common in government and private sector databases</a:t>
+            </a:r>
+          </a:p>
+          <a:p>
+            <a:pPr lvl="0" indent="0" marL="0">
+              <a:buNone/>
+            </a:pPr>
+          </a:p>
+          <a:p>
+            <a:pPr lvl="0"/>
+            <a:r>
+              <a:rPr/>
+              <a:t>Data not properly de-identified</a:t>
+            </a:r>
+          </a:p>
+          <a:p>
+            <a:pPr lvl="0" indent="0" marL="0">
+              <a:buNone/>
+            </a:pPr>
+          </a:p>
+          <a:p>
+            <a:pPr lvl="1"/>
+            <a:r>
+              <a:rPr/>
+              <a:t>Example: In the 1990s, Massachusetts released de-identified medical records of state employees for research. Despite removing names and addresses, a researcher was able to re-identify individuals, including the governor, by combining the data with other publicly available information.</a:t>
+            </a:r>
+          </a:p>
+        </p:txBody>
+      </p:sp>
+      <p:sp>
+        <p:nvSpPr>
+          <p:cNvPr id="4" name="Slide Number Placeholder 3"/>
+          <p:cNvSpPr>
+            <a:spLocks noGrp="1"/>
+          </p:cNvSpPr>
+          <p:nvPr>
+            <p:ph type="sldNum" sz="quarter" idx="10"/>
+          </p:nvPr>
+        </p:nvSpPr>
+        <p:spPr/>
+        <p:txBody>
+          <a:bodyPr/>
+          <a:lstStyle/>
+          <a:p>
+            <a:fld id="{18BDFEC3-8487-43E8-A154-7C12CBC1FFF2}" type="slidenum">
+              <a:rPr lang="en-US"/>
+              <a:t>15</a:t>
+            </a:fld>
+            <a:endParaRPr lang="en-US"/>
+          </a:p>
+        </p:txBody>
+      </p:sp>
+    </p:spTree>
+  </p:cSld>
+</p:notes>
 </file>
 
 <file path=ppt/slideLayouts/slideLayout1.xml><?xml version="1.0" encoding="utf-8"?>
@@ -3152,6 +3657,2266 @@
           </a:p>
         </p:txBody>
       </p:sp>
+    </p:spTree>
+  </p:cSld>
+</p:sld>
+</file>
+
+<file path=ppt/slides/slide10.xml><?xml version="1.0" encoding="utf-8"?>
+<p:sld xmlns:a="http://schemas.openxmlformats.org/drawingml/2006/main" xmlns:r="http://schemas.openxmlformats.org/officeDocument/2006/relationships" xmlns:p="http://schemas.openxmlformats.org/presentationml/2006/main">
+  <p:cSld>
+    <p:spTree>
+      <p:nvGrpSpPr>
+        <p:cNvPr id="1" name=""/>
+        <p:cNvGrpSpPr/>
+        <p:nvPr/>
+      </p:nvGrpSpPr>
+      <p:grpSpPr>
+        <a:xfrm>
+          <a:off x="0" y="0"/>
+          <a:ext cx="0" cy="0"/>
+          <a:chOff x="0" y="0"/>
+          <a:chExt cx="0" cy="0"/>
+        </a:xfrm>
+      </p:grpSpPr>
+      <p:sp>
+        <p:nvSpPr>
+          <p:cNvPr id="2" name="Title 1"/>
+          <p:cNvSpPr>
+            <a:spLocks noGrp="1"/>
+          </p:cNvSpPr>
+          <p:nvPr>
+            <p:ph type="title"/>
+          </p:nvPr>
+        </p:nvSpPr>
+        <p:spPr/>
+        <p:txBody>
+          <a:bodyPr/>
+          <a:lstStyle/>
+          <a:p>
+            <a:pPr lvl="0" indent="0" marL="0">
+              <a:buNone/>
+            </a:pPr>
+            <a:r>
+              <a:rPr/>
+              <a:t>Three pathways for public intent data to add value</a:t>
+            </a:r>
+          </a:p>
+        </p:txBody>
+      </p:sp>
+      <p:sp>
+        <p:nvSpPr>
+          <p:cNvPr id="3" name="Content Placeholder 2"/>
+          <p:cNvSpPr>
+            <a:spLocks noGrp="1"/>
+          </p:cNvSpPr>
+          <p:nvPr>
+            <p:ph idx="1"/>
+          </p:nvPr>
+        </p:nvSpPr>
+        <p:spPr/>
+        <p:txBody>
+          <a:bodyPr/>
+          <a:lstStyle/>
+          <a:p>
+            <a:pPr lvl="0"/>
+            <a:r>
+              <a:rPr/>
+              <a:t>Improving service delivery</a:t>
+            </a:r>
+          </a:p>
+          <a:p>
+            <a:pPr lvl="0"/>
+            <a:r>
+              <a:rPr/>
+              <a:t>Prioritising scarce resources</a:t>
+            </a:r>
+          </a:p>
+          <a:p>
+            <a:pPr lvl="0"/>
+            <a:r>
+              <a:rPr/>
+              <a:t>Holding government accountable and empowering individuals</a:t>
+            </a:r>
+          </a:p>
+        </p:txBody>
+      </p:sp>
+    </p:spTree>
+  </p:cSld>
+</p:sld>
+</file>
+
+<file path=ppt/slides/slide11.xml><?xml version="1.0" encoding="utf-8"?>
+<p:sld xmlns:a="http://schemas.openxmlformats.org/drawingml/2006/main" xmlns:r="http://schemas.openxmlformats.org/officeDocument/2006/relationships" xmlns:p="http://schemas.openxmlformats.org/presentationml/2006/main">
+  <p:cSld>
+    <p:spTree>
+      <p:nvGrpSpPr>
+        <p:cNvPr id="1" name=""/>
+        <p:cNvGrpSpPr/>
+        <p:nvPr/>
+      </p:nvGrpSpPr>
+      <p:grpSpPr>
+        <a:xfrm>
+          <a:off x="0" y="0"/>
+          <a:ext cx="0" cy="0"/>
+          <a:chOff x="0" y="0"/>
+          <a:chExt cx="0" cy="0"/>
+        </a:xfrm>
+      </p:grpSpPr>
+      <p:sp>
+        <p:nvSpPr>
+          <p:cNvPr id="2" name="Title 1"/>
+          <p:cNvSpPr>
+            <a:spLocks noGrp="1"/>
+          </p:cNvSpPr>
+          <p:nvPr>
+            <p:ph type="title"/>
+          </p:nvPr>
+        </p:nvSpPr>
+        <p:spPr/>
+        <p:txBody>
+          <a:bodyPr/>
+          <a:lstStyle/>
+          <a:p>
+            <a:pPr lvl="0" indent="0" marL="0">
+              <a:buNone/>
+            </a:pPr>
+            <a:r>
+              <a:rPr/>
+              <a:t>Gaps in public intent data</a:t>
+            </a:r>
+          </a:p>
+        </p:txBody>
+      </p:sp>
+    </p:spTree>
+  </p:cSld>
+</p:sld>
+</file>
+
+<file path=ppt/slides/slide12.xml><?xml version="1.0" encoding="utf-8"?>
+<p:sld xmlns:a="http://schemas.openxmlformats.org/drawingml/2006/main" xmlns:r="http://schemas.openxmlformats.org/officeDocument/2006/relationships" xmlns:p="http://schemas.openxmlformats.org/presentationml/2006/main">
+  <p:cSld>
+    <p:spTree>
+      <p:nvGrpSpPr>
+        <p:cNvPr id="1" name=""/>
+        <p:cNvGrpSpPr/>
+        <p:nvPr/>
+      </p:nvGrpSpPr>
+      <p:grpSpPr>
+        <a:xfrm>
+          <a:off x="0" y="0"/>
+          <a:ext cx="0" cy="0"/>
+          <a:chOff x="0" y="0"/>
+          <a:chExt cx="0" cy="0"/>
+        </a:xfrm>
+      </p:grpSpPr>
+      <p:sp>
+        <p:nvSpPr>
+          <p:cNvPr id="2" name="Title 1"/>
+          <p:cNvSpPr>
+            <a:spLocks noGrp="1"/>
+          </p:cNvSpPr>
+          <p:nvPr>
+            <p:ph type="title"/>
+          </p:nvPr>
+        </p:nvSpPr>
+        <p:spPr/>
+        <p:txBody>
+          <a:bodyPr/>
+          <a:lstStyle/>
+          <a:p>
+            <a:pPr lvl="0" indent="0" marL="0">
+              <a:buNone/>
+            </a:pPr>
+            <a:r>
+              <a:rPr/>
+              <a:t>Coverage is inadequate</a:t>
+            </a:r>
+          </a:p>
+        </p:txBody>
+      </p:sp>
+      <p:sp>
+        <p:nvSpPr>
+          <p:cNvPr id="3" name="Content Placeholder 2"/>
+          <p:cNvSpPr>
+            <a:spLocks noGrp="1"/>
+          </p:cNvSpPr>
+          <p:nvPr>
+            <p:ph idx="1" sz="half"/>
+          </p:nvPr>
+        </p:nvSpPr>
+        <p:spPr/>
+        <p:txBody>
+          <a:bodyPr/>
+          <a:lstStyle/>
+          <a:p>
+            <a:pPr lvl="0"/>
+            <a:r>
+              <a:rPr/>
+              <a:t>Lack of </a:t>
+            </a:r>
+            <a:r>
+              <a:rPr i="1"/>
+              <a:t>timeliness</a:t>
+            </a:r>
+            <a:r>
+              <a:rPr/>
+              <a:t>, </a:t>
+            </a:r>
+            <a:r>
+              <a:rPr i="1"/>
+              <a:t>frequency</a:t>
+            </a:r>
+            <a:r>
+              <a:rPr/>
+              <a:t>, and </a:t>
+            </a:r>
+            <a:r>
+              <a:rPr i="1"/>
+              <a:t>completeness</a:t>
+            </a:r>
+            <a:r>
+              <a:rPr/>
+              <a:t>.</a:t>
+            </a:r>
+          </a:p>
+          <a:p>
+            <a:pPr lvl="0"/>
+            <a:r>
+              <a:rPr/>
+              <a:t>Large gaps in geospatial data in lower-income countries</a:t>
+            </a:r>
+          </a:p>
+        </p:txBody>
+      </p:sp>
+      <p:pic>
+        <p:nvPicPr>
+          <p:cNvPr descr="../images/data_gap_geospatial.png" id="0" name="Picture 1"/>
+          <p:cNvPicPr>
+            <a:picLocks noGrp="1" noChangeAspect="1"/>
+          </p:cNvPicPr>
+          <p:nvPr/>
+        </p:nvPicPr>
+        <p:blipFill>
+          <a:blip r:embed="rId2"/>
+          <a:stretch>
+            <a:fillRect/>
+          </a:stretch>
+        </p:blipFill>
+        <p:spPr bwMode="auto">
+          <a:xfrm>
+            <a:off x="4648200" y="1219200"/>
+            <a:ext cx="4038600" cy="3340100"/>
+          </a:xfrm>
+          <a:prstGeom prst="rect">
+            <a:avLst/>
+          </a:prstGeom>
+          <a:noFill/>
+          <a:ln w="9525">
+            <a:noFill/>
+            <a:headEnd/>
+            <a:tailEnd/>
+          </a:ln>
+        </p:spPr>
+      </p:pic>
+    </p:spTree>
+  </p:cSld>
+</p:sld>
+</file>
+
+<file path=ppt/slides/slide13.xml><?xml version="1.0" encoding="utf-8"?>
+<p:sld xmlns:a="http://schemas.openxmlformats.org/drawingml/2006/main" xmlns:r="http://schemas.openxmlformats.org/officeDocument/2006/relationships" xmlns:p="http://schemas.openxmlformats.org/presentationml/2006/main">
+  <p:cSld>
+    <p:spTree>
+      <p:nvGrpSpPr>
+        <p:cNvPr id="1" name=""/>
+        <p:cNvGrpSpPr/>
+        <p:nvPr/>
+      </p:nvGrpSpPr>
+      <p:grpSpPr>
+        <a:xfrm>
+          <a:off x="0" y="0"/>
+          <a:ext cx="0" cy="0"/>
+          <a:chOff x="0" y="0"/>
+          <a:chExt cx="0" cy="0"/>
+        </a:xfrm>
+      </p:grpSpPr>
+      <p:sp>
+        <p:nvSpPr>
+          <p:cNvPr id="2" name="Title 1"/>
+          <p:cNvSpPr>
+            <a:spLocks noGrp="1"/>
+          </p:cNvSpPr>
+          <p:nvPr>
+            <p:ph type="title"/>
+          </p:nvPr>
+        </p:nvSpPr>
+        <p:spPr/>
+        <p:txBody>
+          <a:bodyPr/>
+          <a:lstStyle/>
+          <a:p>
+            <a:pPr lvl="0" indent="0" marL="0">
+              <a:buNone/>
+            </a:pPr>
+            <a:r>
+              <a:rPr/>
+              <a:t>Data quality is poor</a:t>
+            </a:r>
+          </a:p>
+        </p:txBody>
+      </p:sp>
+      <p:sp>
+        <p:nvSpPr>
+          <p:cNvPr id="3" name="Content Placeholder 2"/>
+          <p:cNvSpPr>
+            <a:spLocks noGrp="1"/>
+          </p:cNvSpPr>
+          <p:nvPr>
+            <p:ph idx="1" sz="half"/>
+          </p:nvPr>
+        </p:nvSpPr>
+        <p:spPr/>
+        <p:txBody>
+          <a:bodyPr/>
+          <a:lstStyle/>
+          <a:p>
+            <a:pPr lvl="0"/>
+            <a:r>
+              <a:rPr/>
+              <a:t>Lack of </a:t>
+            </a:r>
+            <a:r>
+              <a:rPr i="1"/>
+              <a:t>granularity</a:t>
+            </a:r>
+            <a:r>
+              <a:rPr/>
+              <a:t>, </a:t>
+            </a:r>
+            <a:r>
+              <a:rPr i="1"/>
+              <a:t>accuracy</a:t>
+            </a:r>
+            <a:r>
+              <a:rPr/>
+              <a:t>, and </a:t>
+            </a:r>
+            <a:r>
+              <a:rPr i="1"/>
+              <a:t>comparability</a:t>
+            </a:r>
+            <a:r>
+              <a:rPr/>
+              <a:t>.</a:t>
+            </a:r>
+          </a:p>
+          <a:p>
+            <a:pPr lvl="0"/>
+            <a:r>
+              <a:rPr/>
+              <a:t>Lack of data disaggregation</a:t>
+            </a:r>
+          </a:p>
+          <a:p>
+            <a:pPr lvl="0"/>
+            <a:r>
+              <a:rPr/>
+              <a:t>Lower-income countries have less comparable poverty data</a:t>
+            </a:r>
+          </a:p>
+        </p:txBody>
+      </p:sp>
+      <p:pic>
+        <p:nvPicPr>
+          <p:cNvPr descr="../images/data_comparability_poverty.png" id="0" name="Picture 1"/>
+          <p:cNvPicPr>
+            <a:picLocks noGrp="1" noChangeAspect="1"/>
+          </p:cNvPicPr>
+          <p:nvPr/>
+        </p:nvPicPr>
+        <p:blipFill>
+          <a:blip r:embed="rId2"/>
+          <a:stretch>
+            <a:fillRect/>
+          </a:stretch>
+        </p:blipFill>
+        <p:spPr bwMode="auto">
+          <a:xfrm>
+            <a:off x="4648200" y="1841500"/>
+            <a:ext cx="4038600" cy="2082800"/>
+          </a:xfrm>
+          <a:prstGeom prst="rect">
+            <a:avLst/>
+          </a:prstGeom>
+          <a:noFill/>
+          <a:ln w="9525">
+            <a:noFill/>
+            <a:headEnd/>
+            <a:tailEnd/>
+          </a:ln>
+        </p:spPr>
+      </p:pic>
+    </p:spTree>
+  </p:cSld>
+</p:sld>
+</file>
+
+<file path=ppt/slides/slide14.xml><?xml version="1.0" encoding="utf-8"?>
+<p:sld xmlns:a="http://schemas.openxmlformats.org/drawingml/2006/main" xmlns:r="http://schemas.openxmlformats.org/officeDocument/2006/relationships" xmlns:p="http://schemas.openxmlformats.org/presentationml/2006/main">
+  <p:cSld>
+    <p:spTree>
+      <p:nvGrpSpPr>
+        <p:cNvPr id="1" name=""/>
+        <p:cNvGrpSpPr/>
+        <p:nvPr/>
+      </p:nvGrpSpPr>
+      <p:grpSpPr>
+        <a:xfrm>
+          <a:off x="0" y="0"/>
+          <a:ext cx="0" cy="0"/>
+          <a:chOff x="0" y="0"/>
+          <a:chExt cx="0" cy="0"/>
+        </a:xfrm>
+      </p:grpSpPr>
+      <p:sp>
+        <p:nvSpPr>
+          <p:cNvPr id="2" name="Title 1"/>
+          <p:cNvSpPr>
+            <a:spLocks noGrp="1"/>
+          </p:cNvSpPr>
+          <p:nvPr>
+            <p:ph type="title"/>
+          </p:nvPr>
+        </p:nvSpPr>
+        <p:spPr/>
+        <p:txBody>
+          <a:bodyPr/>
+          <a:lstStyle/>
+          <a:p>
+            <a:pPr lvl="0" indent="0" marL="0">
+              <a:buNone/>
+            </a:pPr>
+            <a:r>
+              <a:rPr/>
+              <a:t>Data not easy to use</a:t>
+            </a:r>
+          </a:p>
+        </p:txBody>
+      </p:sp>
+      <p:sp>
+        <p:nvSpPr>
+          <p:cNvPr id="3" name="Content Placeholder 2"/>
+          <p:cNvSpPr>
+            <a:spLocks noGrp="1"/>
+          </p:cNvSpPr>
+          <p:nvPr>
+            <p:ph idx="1"/>
+          </p:nvPr>
+        </p:nvSpPr>
+        <p:spPr/>
+        <p:txBody>
+          <a:bodyPr/>
+          <a:lstStyle/>
+          <a:p>
+            <a:pPr lvl="0"/>
+            <a:r>
+              <a:rPr/>
+              <a:t>Lack of </a:t>
+            </a:r>
+            <a:r>
+              <a:rPr i="1"/>
+              <a:t>accessibility</a:t>
+            </a:r>
+            <a:r>
+              <a:rPr/>
+              <a:t>, </a:t>
+            </a:r>
+            <a:r>
+              <a:rPr i="1"/>
+              <a:t>understandability</a:t>
+            </a:r>
+            <a:r>
+              <a:rPr/>
+              <a:t>, and </a:t>
+            </a:r>
+            <a:r>
+              <a:rPr i="1"/>
+              <a:t>interoperability</a:t>
+            </a:r>
+            <a:r>
+              <a:rPr/>
+              <a:t>.</a:t>
+            </a:r>
+          </a:p>
+        </p:txBody>
+      </p:sp>
+    </p:spTree>
+  </p:cSld>
+</p:sld>
+</file>
+
+<file path=ppt/slides/slide15.xml><?xml version="1.0" encoding="utf-8"?>
+<p:sld xmlns:a="http://schemas.openxmlformats.org/drawingml/2006/main" xmlns:r="http://schemas.openxmlformats.org/officeDocument/2006/relationships" xmlns:p="http://schemas.openxmlformats.org/presentationml/2006/main">
+  <p:cSld>
+    <p:spTree>
+      <p:nvGrpSpPr>
+        <p:cNvPr id="1" name=""/>
+        <p:cNvGrpSpPr/>
+        <p:nvPr/>
+      </p:nvGrpSpPr>
+      <p:grpSpPr>
+        <a:xfrm>
+          <a:off x="0" y="0"/>
+          <a:ext cx="0" cy="0"/>
+          <a:chOff x="0" y="0"/>
+          <a:chExt cx="0" cy="0"/>
+        </a:xfrm>
+      </p:grpSpPr>
+      <p:sp>
+        <p:nvSpPr>
+          <p:cNvPr id="2" name="Title 1"/>
+          <p:cNvSpPr>
+            <a:spLocks noGrp="1"/>
+          </p:cNvSpPr>
+          <p:nvPr>
+            <p:ph type="title"/>
+          </p:nvPr>
+        </p:nvSpPr>
+        <p:spPr/>
+        <p:txBody>
+          <a:bodyPr/>
+          <a:lstStyle/>
+          <a:p>
+            <a:pPr lvl="0" indent="0" marL="0">
+              <a:buNone/>
+            </a:pPr>
+            <a:r>
+              <a:rPr/>
+              <a:t>Data not safe to use</a:t>
+            </a:r>
+          </a:p>
+        </p:txBody>
+      </p:sp>
+      <p:sp>
+        <p:nvSpPr>
+          <p:cNvPr id="3" name="Content Placeholder 2"/>
+          <p:cNvSpPr>
+            <a:spLocks noGrp="1"/>
+          </p:cNvSpPr>
+          <p:nvPr>
+            <p:ph idx="1"/>
+          </p:nvPr>
+        </p:nvSpPr>
+        <p:spPr/>
+        <p:txBody>
+          <a:bodyPr/>
+          <a:lstStyle/>
+          <a:p>
+            <a:pPr lvl="0"/>
+            <a:r>
+              <a:rPr/>
+              <a:t>Data not immune to influence from stakeholders</a:t>
+            </a:r>
+          </a:p>
+          <a:p>
+            <a:pPr lvl="0"/>
+            <a:r>
+              <a:rPr/>
+              <a:t>Data not stored securely - too common in government and private sector databases</a:t>
+            </a:r>
+          </a:p>
+          <a:p>
+            <a:pPr lvl="0"/>
+            <a:r>
+              <a:rPr/>
+              <a:t>Data not properly de-identified</a:t>
+            </a:r>
+          </a:p>
+        </p:txBody>
+      </p:sp>
+    </p:spTree>
+  </p:cSld>
+</p:sld>
+</file>
+
+<file path=ppt/slides/slide16.xml><?xml version="1.0" encoding="utf-8"?>
+<p:sld xmlns:a="http://schemas.openxmlformats.org/drawingml/2006/main" xmlns:r="http://schemas.openxmlformats.org/officeDocument/2006/relationships" xmlns:p="http://schemas.openxmlformats.org/presentationml/2006/main">
+  <p:cSld>
+    <p:spTree>
+      <p:nvGrpSpPr>
+        <p:cNvPr id="1" name=""/>
+        <p:cNvGrpSpPr/>
+        <p:nvPr/>
+      </p:nvGrpSpPr>
+      <p:grpSpPr>
+        <a:xfrm>
+          <a:off x="0" y="0"/>
+          <a:ext cx="0" cy="0"/>
+          <a:chOff x="0" y="0"/>
+          <a:chExt cx="0" cy="0"/>
+        </a:xfrm>
+      </p:grpSpPr>
+      <p:sp>
+        <p:nvSpPr>
+          <p:cNvPr id="2" name="Title 1"/>
+          <p:cNvSpPr>
+            <a:spLocks noGrp="1"/>
+          </p:cNvSpPr>
+          <p:nvPr>
+            <p:ph type="title"/>
+          </p:nvPr>
+        </p:nvSpPr>
+        <p:spPr/>
+        <p:txBody>
+          <a:bodyPr/>
+          <a:lstStyle/>
+          <a:p>
+            <a:pPr lvl="0" indent="0" marL="0">
+              <a:buNone/>
+            </a:pPr>
+            <a:r>
+              <a:rPr/>
+              <a:t>Why gaps persist</a:t>
+            </a:r>
+          </a:p>
+        </p:txBody>
+      </p:sp>
+      <p:sp>
+        <p:nvSpPr>
+          <p:cNvPr id="3" name="Content Placeholder 2"/>
+          <p:cNvSpPr>
+            <a:spLocks noGrp="1"/>
+          </p:cNvSpPr>
+          <p:nvPr>
+            <p:ph idx="1"/>
+          </p:nvPr>
+        </p:nvSpPr>
+        <p:spPr/>
+        <p:txBody>
+          <a:bodyPr/>
+          <a:lstStyle/>
+          <a:p>
+            <a:pPr lvl="0"/>
+            <a:r>
+              <a:rPr/>
+              <a:t>Deficiencies in financing</a:t>
+            </a:r>
+          </a:p>
+          <a:p>
+            <a:pPr lvl="0"/>
+            <a:r>
+              <a:rPr/>
+              <a:t>Deficiencies in technical capacity</a:t>
+            </a:r>
+          </a:p>
+          <a:p>
+            <a:pPr lvl="0"/>
+            <a:r>
+              <a:rPr/>
+              <a:t>Deficiencies in governance</a:t>
+            </a:r>
+          </a:p>
+          <a:p>
+            <a:pPr lvl="0"/>
+            <a:r>
+              <a:rPr/>
+              <a:t>Deficiencies in data demand</a:t>
+            </a:r>
+          </a:p>
+        </p:txBody>
+      </p:sp>
+    </p:spTree>
+  </p:cSld>
+</p:sld>
+</file>
+
+<file path=ppt/slides/slide17.xml><?xml version="1.0" encoding="utf-8"?>
+<p:sld xmlns:a="http://schemas.openxmlformats.org/drawingml/2006/main" xmlns:r="http://schemas.openxmlformats.org/officeDocument/2006/relationships" xmlns:p="http://schemas.openxmlformats.org/presentationml/2006/main">
+  <p:cSld>
+    <p:spTree>
+      <p:nvGrpSpPr>
+        <p:cNvPr id="1" name=""/>
+        <p:cNvGrpSpPr/>
+        <p:nvPr/>
+      </p:nvGrpSpPr>
+      <p:grpSpPr>
+        <a:xfrm>
+          <a:off x="0" y="0"/>
+          <a:ext cx="0" cy="0"/>
+          <a:chOff x="0" y="0"/>
+          <a:chExt cx="0" cy="0"/>
+        </a:xfrm>
+      </p:grpSpPr>
+      <p:sp>
+        <p:nvSpPr>
+          <p:cNvPr id="2" name="Title 1"/>
+          <p:cNvSpPr>
+            <a:spLocks noGrp="1"/>
+          </p:cNvSpPr>
+          <p:nvPr>
+            <p:ph type="title"/>
+          </p:nvPr>
+        </p:nvSpPr>
+        <p:spPr/>
+        <p:txBody>
+          <a:bodyPr/>
+          <a:lstStyle/>
+          <a:p>
+            <a:pPr lvl="0" indent="0" marL="0">
+              <a:buNone/>
+            </a:pPr>
+            <a:r>
+              <a:rPr/>
+              <a:t>Data in the production process</a:t>
+            </a:r>
+          </a:p>
+        </p:txBody>
+      </p:sp>
+      <p:pic>
+        <p:nvPicPr>
+          <p:cNvPr descr="../images/data_in_production.png" id="0" name="Picture 1"/>
+          <p:cNvPicPr>
+            <a:picLocks noGrp="1" noChangeAspect="1"/>
+          </p:cNvPicPr>
+          <p:nvPr/>
+        </p:nvPicPr>
+        <p:blipFill>
+          <a:blip r:embed="rId2"/>
+          <a:stretch>
+            <a:fillRect/>
+          </a:stretch>
+        </p:blipFill>
+        <p:spPr bwMode="auto">
+          <a:xfrm>
+            <a:off x="1727200" y="1193800"/>
+            <a:ext cx="5676900" cy="3390900"/>
+          </a:xfrm>
+          <a:prstGeom prst="rect">
+            <a:avLst/>
+          </a:prstGeom>
+          <a:noFill/>
+          <a:ln w="9525">
+            <a:noFill/>
+            <a:headEnd/>
+            <a:tailEnd/>
+          </a:ln>
+        </p:spPr>
+      </p:pic>
+    </p:spTree>
+  </p:cSld>
+</p:sld>
+</file>
+
+<file path=ppt/slides/slide18.xml><?xml version="1.0" encoding="utf-8"?>
+<p:sld xmlns:a="http://schemas.openxmlformats.org/drawingml/2006/main" xmlns:r="http://schemas.openxmlformats.org/officeDocument/2006/relationships" xmlns:p="http://schemas.openxmlformats.org/presentationml/2006/main">
+  <p:cSld>
+    <p:spTree>
+      <p:nvGrpSpPr>
+        <p:cNvPr id="1" name=""/>
+        <p:cNvGrpSpPr/>
+        <p:nvPr/>
+      </p:nvGrpSpPr>
+      <p:grpSpPr>
+        <a:xfrm>
+          <a:off x="0" y="0"/>
+          <a:ext cx="0" cy="0"/>
+          <a:chOff x="0" y="0"/>
+          <a:chExt cx="0" cy="0"/>
+        </a:xfrm>
+      </p:grpSpPr>
+      <p:sp>
+        <p:nvSpPr>
+          <p:cNvPr id="2" name="Title 1"/>
+          <p:cNvSpPr>
+            <a:spLocks noGrp="1"/>
+          </p:cNvSpPr>
+          <p:nvPr>
+            <p:ph type="title"/>
+          </p:nvPr>
+        </p:nvSpPr>
+        <p:spPr/>
+        <p:txBody>
+          <a:bodyPr/>
+          <a:lstStyle/>
+          <a:p>
+            <a:pPr lvl="0" indent="0" marL="0">
+              <a:buNone/>
+            </a:pPr>
+            <a:r>
+              <a:rPr/>
+              <a:t>Role of data in economic activity</a:t>
+            </a:r>
+          </a:p>
+        </p:txBody>
+      </p:sp>
+      <p:pic>
+        <p:nvPicPr>
+          <p:cNvPr descr="../images/data_in_economic_activity.png" id="0" name="Picture 1"/>
+          <p:cNvPicPr>
+            <a:picLocks noGrp="1" noChangeAspect="1"/>
+          </p:cNvPicPr>
+          <p:nvPr/>
+        </p:nvPicPr>
+        <p:blipFill>
+          <a:blip r:embed="rId2"/>
+          <a:stretch>
+            <a:fillRect/>
+          </a:stretch>
+        </p:blipFill>
+        <p:spPr bwMode="auto">
+          <a:xfrm>
+            <a:off x="2413000" y="1193800"/>
+            <a:ext cx="4305300" cy="3390900"/>
+          </a:xfrm>
+          <a:prstGeom prst="rect">
+            <a:avLst/>
+          </a:prstGeom>
+          <a:noFill/>
+          <a:ln w="9525">
+            <a:noFill/>
+            <a:headEnd/>
+            <a:tailEnd/>
+          </a:ln>
+        </p:spPr>
+      </p:pic>
+    </p:spTree>
+  </p:cSld>
+</p:sld>
+</file>
+
+<file path=ppt/slides/slide19.xml><?xml version="1.0" encoding="utf-8"?>
+<p:sld xmlns:a="http://schemas.openxmlformats.org/drawingml/2006/main" xmlns:r="http://schemas.openxmlformats.org/officeDocument/2006/relationships" xmlns:p="http://schemas.openxmlformats.org/presentationml/2006/main">
+  <p:cSld>
+    <p:spTree>
+      <p:nvGrpSpPr>
+        <p:cNvPr id="1" name=""/>
+        <p:cNvGrpSpPr/>
+        <p:nvPr/>
+      </p:nvGrpSpPr>
+      <p:grpSpPr>
+        <a:xfrm>
+          <a:off x="0" y="0"/>
+          <a:ext cx="0" cy="0"/>
+          <a:chOff x="0" y="0"/>
+          <a:chExt cx="0" cy="0"/>
+        </a:xfrm>
+      </p:grpSpPr>
+      <p:sp>
+        <p:nvSpPr>
+          <p:cNvPr id="2" name="Title 1"/>
+          <p:cNvSpPr>
+            <a:spLocks noGrp="1"/>
+          </p:cNvSpPr>
+          <p:nvPr>
+            <p:ph type="title"/>
+          </p:nvPr>
+        </p:nvSpPr>
+        <p:spPr/>
+        <p:txBody>
+          <a:bodyPr/>
+          <a:lstStyle/>
+          <a:p>
+            <a:pPr lvl="0" indent="0" marL="0">
+              <a:buNone/>
+            </a:pPr>
+            <a:r>
+              <a:rPr/>
+              <a:t>Data inputs for economic activity</a:t>
+            </a:r>
+          </a:p>
+        </p:txBody>
+      </p:sp>
+      <p:sp>
+        <p:nvSpPr>
+          <p:cNvPr id="3" name="Content Placeholder 2"/>
+          <p:cNvSpPr>
+            <a:spLocks noGrp="1"/>
+          </p:cNvSpPr>
+          <p:nvPr>
+            <p:ph idx="1"/>
+          </p:nvPr>
+        </p:nvSpPr>
+        <p:spPr/>
+        <p:txBody>
+          <a:bodyPr/>
+          <a:lstStyle/>
+          <a:p>
+            <a:pPr lvl="0"/>
+            <a:r>
+              <a:rPr/>
+              <a:t>Data collection by firms - </a:t>
+            </a:r>
+            <a:r>
+              <a:rPr b="1"/>
+              <a:t>“digital footprint”</a:t>
+            </a:r>
+          </a:p>
+          <a:p>
+            <a:pPr lvl="0"/>
+            <a:r>
+              <a:rPr/>
+              <a:t>Use of public intent data by businesses</a:t>
+            </a:r>
+          </a:p>
+        </p:txBody>
+      </p:sp>
+    </p:spTree>
+  </p:cSld>
+</p:sld>
+</file>
+
+<file path=ppt/slides/slide2.xml><?xml version="1.0" encoding="utf-8"?>
+<p:sld xmlns:a="http://schemas.openxmlformats.org/drawingml/2006/main" xmlns:r="http://schemas.openxmlformats.org/officeDocument/2006/relationships" xmlns:p="http://schemas.openxmlformats.org/presentationml/2006/main">
+  <p:cSld>
+    <p:spTree>
+      <p:nvGrpSpPr>
+        <p:cNvPr id="1" name=""/>
+        <p:cNvGrpSpPr/>
+        <p:nvPr/>
+      </p:nvGrpSpPr>
+      <p:grpSpPr>
+        <a:xfrm>
+          <a:off x="0" y="0"/>
+          <a:ext cx="0" cy="0"/>
+          <a:chOff x="0" y="0"/>
+          <a:chExt cx="0" cy="0"/>
+        </a:xfrm>
+      </p:grpSpPr>
+      <p:sp>
+        <p:nvSpPr>
+          <p:cNvPr id="2" name="Title 1"/>
+          <p:cNvSpPr>
+            <a:spLocks noGrp="1"/>
+          </p:cNvSpPr>
+          <p:nvPr>
+            <p:ph type="title"/>
+          </p:nvPr>
+        </p:nvSpPr>
+        <p:spPr/>
+        <p:txBody>
+          <a:bodyPr/>
+          <a:lstStyle/>
+          <a:p>
+            <a:pPr lvl="0" indent="0" marL="0">
+              <a:buNone/>
+            </a:pPr>
+            <a:r>
+              <a:rPr/>
+              <a:t>Outline</a:t>
+            </a:r>
+          </a:p>
+        </p:txBody>
+      </p:sp>
+      <p:sp>
+        <p:nvSpPr>
+          <p:cNvPr id="3" name="Content Placeholder 2"/>
+          <p:cNvSpPr>
+            <a:spLocks noGrp="1"/>
+          </p:cNvSpPr>
+          <p:nvPr>
+            <p:ph idx="1"/>
+          </p:nvPr>
+        </p:nvSpPr>
+        <p:spPr/>
+        <p:txBody>
+          <a:bodyPr/>
+          <a:lstStyle/>
+          <a:p>
+            <a:pPr lvl="0"/>
+            <a:r>
+              <a:rPr/>
+              <a:t>Definitions</a:t>
+            </a:r>
+          </a:p>
+        </p:txBody>
+      </p:sp>
+    </p:spTree>
+  </p:cSld>
+</p:sld>
+</file>
+
+<file path=ppt/slides/slide20.xml><?xml version="1.0" encoding="utf-8"?>
+<p:sld xmlns:a="http://schemas.openxmlformats.org/drawingml/2006/main" xmlns:r="http://schemas.openxmlformats.org/officeDocument/2006/relationships" xmlns:p="http://schemas.openxmlformats.org/presentationml/2006/main">
+  <p:cSld>
+    <p:spTree>
+      <p:nvGrpSpPr>
+        <p:cNvPr id="1" name=""/>
+        <p:cNvGrpSpPr/>
+        <p:nvPr/>
+      </p:nvGrpSpPr>
+      <p:grpSpPr>
+        <a:xfrm>
+          <a:off x="0" y="0"/>
+          <a:ext cx="0" cy="0"/>
+          <a:chOff x="0" y="0"/>
+          <a:chExt cx="0" cy="0"/>
+        </a:xfrm>
+      </p:grpSpPr>
+      <p:sp>
+        <p:nvSpPr>
+          <p:cNvPr id="2" name="Title 1"/>
+          <p:cNvSpPr>
+            <a:spLocks noGrp="1"/>
+          </p:cNvSpPr>
+          <p:nvPr>
+            <p:ph type="title"/>
+          </p:nvPr>
+        </p:nvSpPr>
+        <p:spPr/>
+        <p:txBody>
+          <a:bodyPr/>
+          <a:lstStyle/>
+          <a:p>
+            <a:pPr lvl="0" indent="0" marL="0">
+              <a:buNone/>
+            </a:pPr>
+            <a:r>
+              <a:rPr/>
+              <a:t>Sectors transformed by use of data in the production process</a:t>
+            </a:r>
+          </a:p>
+        </p:txBody>
+      </p:sp>
+      <p:sp>
+        <p:nvSpPr>
+          <p:cNvPr id="3" name="Content Placeholder 2"/>
+          <p:cNvSpPr>
+            <a:spLocks noGrp="1"/>
+          </p:cNvSpPr>
+          <p:nvPr>
+            <p:ph idx="1"/>
+          </p:nvPr>
+        </p:nvSpPr>
+        <p:spPr/>
+        <p:txBody>
+          <a:bodyPr/>
+          <a:lstStyle/>
+          <a:p>
+            <a:pPr lvl="0"/>
+            <a:r>
+              <a:rPr/>
+              <a:t>Finance</a:t>
+            </a:r>
+          </a:p>
+          <a:p>
+            <a:pPr lvl="0"/>
+            <a:r>
+              <a:rPr/>
+              <a:t>Agriculture</a:t>
+            </a:r>
+          </a:p>
+          <a:p>
+            <a:pPr lvl="0"/>
+            <a:r>
+              <a:rPr/>
+              <a:t>Health</a:t>
+            </a:r>
+          </a:p>
+          <a:p>
+            <a:pPr lvl="0"/>
+            <a:r>
+              <a:rPr/>
+              <a:t>Education</a:t>
+            </a:r>
+          </a:p>
+          <a:p>
+            <a:pPr lvl="0"/>
+            <a:r>
+              <a:rPr/>
+              <a:t>Transport and logistics</a:t>
+            </a:r>
+          </a:p>
+        </p:txBody>
+      </p:sp>
+    </p:spTree>
+  </p:cSld>
+</p:sld>
+</file>
+
+<file path=ppt/slides/slide21.xml><?xml version="1.0" encoding="utf-8"?>
+<p:sld xmlns:a="http://schemas.openxmlformats.org/drawingml/2006/main" xmlns:r="http://schemas.openxmlformats.org/officeDocument/2006/relationships" xmlns:p="http://schemas.openxmlformats.org/presentationml/2006/main">
+  <p:cSld>
+    <p:spTree>
+      <p:nvGrpSpPr>
+        <p:cNvPr id="1" name=""/>
+        <p:cNvGrpSpPr/>
+        <p:nvPr/>
+      </p:nvGrpSpPr>
+      <p:grpSpPr>
+        <a:xfrm>
+          <a:off x="0" y="0"/>
+          <a:ext cx="0" cy="0"/>
+          <a:chOff x="0" y="0"/>
+          <a:chExt cx="0" cy="0"/>
+        </a:xfrm>
+      </p:grpSpPr>
+      <p:sp>
+        <p:nvSpPr>
+          <p:cNvPr id="2" name="Title 1"/>
+          <p:cNvSpPr>
+            <a:spLocks noGrp="1"/>
+          </p:cNvSpPr>
+          <p:nvPr>
+            <p:ph type="title"/>
+          </p:nvPr>
+        </p:nvSpPr>
+        <p:spPr/>
+        <p:txBody>
+          <a:bodyPr/>
+          <a:lstStyle/>
+          <a:p>
+            <a:pPr lvl="0" indent="0" marL="0">
+              <a:buNone/>
+            </a:pPr>
+            <a:r>
+              <a:rPr/>
+              <a:t>Finance sector</a:t>
+            </a:r>
+          </a:p>
+        </p:txBody>
+      </p:sp>
+      <p:sp>
+        <p:nvSpPr>
+          <p:cNvPr id="3" name="Content Placeholder 2"/>
+          <p:cNvSpPr>
+            <a:spLocks noGrp="1"/>
+          </p:cNvSpPr>
+          <p:nvPr>
+            <p:ph idx="1"/>
+          </p:nvPr>
+        </p:nvSpPr>
+        <p:spPr/>
+        <p:txBody>
+          <a:bodyPr/>
+          <a:lstStyle/>
+          <a:p>
+            <a:pPr lvl="0"/>
+            <a:r>
+              <a:rPr b="1"/>
+              <a:t>Alternative credit scoring algorithms</a:t>
+            </a:r>
+            <a:r>
+              <a:rPr/>
+              <a:t> - use of an individual’s digital footprint to train machine learning algorithms to identify, score, and underwrite credit.</a:t>
+            </a:r>
+          </a:p>
+          <a:p>
+            <a:pPr lvl="0"/>
+            <a:r>
+              <a:rPr b="1"/>
+              <a:t>Payment systems</a:t>
+            </a:r>
+            <a:r>
+              <a:rPr/>
+              <a:t> - digital payments; mobile payments.</a:t>
+            </a:r>
+          </a:p>
+          <a:p>
+            <a:pPr lvl="0"/>
+            <a:r>
+              <a:rPr b="1"/>
+              <a:t>Use of transaction data for product development</a:t>
+            </a:r>
+            <a:r>
+              <a:rPr/>
+              <a:t> - Mastercard’s Tourism Insights service allows leveraging big data to provide information on travellers’ preferences.</a:t>
+            </a:r>
+          </a:p>
+          <a:p>
+            <a:pPr lvl="0"/>
+            <a:r>
+              <a:rPr b="1"/>
+              <a:t>Distributed ledger technology</a:t>
+            </a:r>
+            <a:r>
+              <a:rPr/>
+              <a:t> - blockchain; eliminates financial intermediaries; embedding rules into smart contracts simplifies negotiation and verification processes.</a:t>
+            </a:r>
+          </a:p>
+        </p:txBody>
+      </p:sp>
+    </p:spTree>
+  </p:cSld>
+</p:sld>
+</file>
+
+<file path=ppt/slides/slide22.xml><?xml version="1.0" encoding="utf-8"?>
+<p:sld xmlns:a="http://schemas.openxmlformats.org/drawingml/2006/main" xmlns:r="http://schemas.openxmlformats.org/officeDocument/2006/relationships" xmlns:p="http://schemas.openxmlformats.org/presentationml/2006/main">
+  <p:cSld>
+    <p:spTree>
+      <p:nvGrpSpPr>
+        <p:cNvPr id="1" name=""/>
+        <p:cNvGrpSpPr/>
+        <p:nvPr/>
+      </p:nvGrpSpPr>
+      <p:grpSpPr>
+        <a:xfrm>
+          <a:off x="0" y="0"/>
+          <a:ext cx="0" cy="0"/>
+          <a:chOff x="0" y="0"/>
+          <a:chExt cx="0" cy="0"/>
+        </a:xfrm>
+      </p:grpSpPr>
+      <p:sp>
+        <p:nvSpPr>
+          <p:cNvPr id="2" name="Title 1"/>
+          <p:cNvSpPr>
+            <a:spLocks noGrp="1"/>
+          </p:cNvSpPr>
+          <p:nvPr>
+            <p:ph type="title"/>
+          </p:nvPr>
+        </p:nvSpPr>
+        <p:spPr/>
+        <p:txBody>
+          <a:bodyPr/>
+          <a:lstStyle/>
+          <a:p>
+            <a:pPr lvl="0" indent="0" marL="0">
+              <a:buNone/>
+            </a:pPr>
+            <a:r>
+              <a:rPr/>
+              <a:t>Agriculture sector</a:t>
+            </a:r>
+          </a:p>
+        </p:txBody>
+      </p:sp>
+      <p:sp>
+        <p:nvSpPr>
+          <p:cNvPr id="3" name="Content Placeholder 2"/>
+          <p:cNvSpPr>
+            <a:spLocks noGrp="1"/>
+          </p:cNvSpPr>
+          <p:nvPr>
+            <p:ph idx="1"/>
+          </p:nvPr>
+        </p:nvSpPr>
+        <p:spPr/>
+        <p:txBody>
+          <a:bodyPr/>
+          <a:lstStyle/>
+          <a:p>
+            <a:pPr lvl="0"/>
+            <a:r>
+              <a:rPr/>
+              <a:t>Remote sensing and geographic information systems - analysis of these data provide insights into farming operations; smart farming</a:t>
+            </a:r>
+          </a:p>
+          <a:p>
+            <a:pPr lvl="0"/>
+            <a:r>
+              <a:rPr/>
+              <a:t>Internet-of-things (IoT) and embedded devices for monitoring farm and livestock conditions and farm operations</a:t>
+            </a:r>
+          </a:p>
+          <a:p>
+            <a:pPr lvl="0"/>
+            <a:r>
+              <a:rPr/>
+              <a:t>Use of data to provide a range of services along the agriculture value chain</a:t>
+            </a:r>
+          </a:p>
+          <a:p>
+            <a:pPr lvl="0"/>
+            <a:r>
+              <a:rPr/>
+              <a:t>Use of data to improve food traceability</a:t>
+            </a:r>
+          </a:p>
+        </p:txBody>
+      </p:sp>
+    </p:spTree>
+  </p:cSld>
+</p:sld>
+</file>
+
+<file path=ppt/slides/slide23.xml><?xml version="1.0" encoding="utf-8"?>
+<p:sld xmlns:a="http://schemas.openxmlformats.org/drawingml/2006/main" xmlns:r="http://schemas.openxmlformats.org/officeDocument/2006/relationships" xmlns:p="http://schemas.openxmlformats.org/presentationml/2006/main">
+  <p:cSld>
+    <p:spTree>
+      <p:nvGrpSpPr>
+        <p:cNvPr id="1" name=""/>
+        <p:cNvGrpSpPr/>
+        <p:nvPr/>
+      </p:nvGrpSpPr>
+      <p:grpSpPr>
+        <a:xfrm>
+          <a:off x="0" y="0"/>
+          <a:ext cx="0" cy="0"/>
+          <a:chOff x="0" y="0"/>
+          <a:chExt cx="0" cy="0"/>
+        </a:xfrm>
+      </p:grpSpPr>
+      <p:sp>
+        <p:nvSpPr>
+          <p:cNvPr id="2" name="Title 1"/>
+          <p:cNvSpPr>
+            <a:spLocks noGrp="1"/>
+          </p:cNvSpPr>
+          <p:nvPr>
+            <p:ph type="title"/>
+          </p:nvPr>
+        </p:nvSpPr>
+        <p:spPr/>
+        <p:txBody>
+          <a:bodyPr/>
+          <a:lstStyle/>
+          <a:p>
+            <a:pPr lvl="0" indent="0" marL="0">
+              <a:buNone/>
+            </a:pPr>
+            <a:r>
+              <a:rPr/>
+              <a:t>Education</a:t>
+            </a:r>
+          </a:p>
+        </p:txBody>
+      </p:sp>
+      <p:sp>
+        <p:nvSpPr>
+          <p:cNvPr id="3" name="Content Placeholder 2"/>
+          <p:cNvSpPr>
+            <a:spLocks noGrp="1"/>
+          </p:cNvSpPr>
+          <p:nvPr>
+            <p:ph idx="1"/>
+          </p:nvPr>
+        </p:nvSpPr>
+        <p:spPr/>
+        <p:txBody>
+          <a:bodyPr/>
+          <a:lstStyle/>
+          <a:p>
+            <a:pPr lvl="0"/>
+            <a:r>
+              <a:rPr/>
+              <a:t>video conferencing/video communication tools</a:t>
+            </a:r>
+          </a:p>
+          <a:p>
+            <a:pPr lvl="0"/>
+            <a:r>
+              <a:rPr/>
+              <a:t>digital supplemental learning platforms</a:t>
+            </a:r>
+          </a:p>
+          <a:p>
+            <a:pPr lvl="0"/>
+            <a:r>
+              <a:rPr/>
+              <a:t>intelligent adaptive education</a:t>
+            </a:r>
+          </a:p>
+        </p:txBody>
+      </p:sp>
+    </p:spTree>
+  </p:cSld>
+</p:sld>
+</file>
+
+<file path=ppt/slides/slide24.xml><?xml version="1.0" encoding="utf-8"?>
+<p:sld xmlns:a="http://schemas.openxmlformats.org/drawingml/2006/main" xmlns:r="http://schemas.openxmlformats.org/officeDocument/2006/relationships" xmlns:p="http://schemas.openxmlformats.org/presentationml/2006/main">
+  <p:cSld>
+    <p:spTree>
+      <p:nvGrpSpPr>
+        <p:cNvPr id="1" name=""/>
+        <p:cNvGrpSpPr/>
+        <p:nvPr/>
+      </p:nvGrpSpPr>
+      <p:grpSpPr>
+        <a:xfrm>
+          <a:off x="0" y="0"/>
+          <a:ext cx="0" cy="0"/>
+          <a:chOff x="0" y="0"/>
+          <a:chExt cx="0" cy="0"/>
+        </a:xfrm>
+      </p:grpSpPr>
+      <p:sp>
+        <p:nvSpPr>
+          <p:cNvPr id="2" name="Title 1"/>
+          <p:cNvSpPr>
+            <a:spLocks noGrp="1"/>
+          </p:cNvSpPr>
+          <p:nvPr>
+            <p:ph type="title"/>
+          </p:nvPr>
+        </p:nvSpPr>
+        <p:spPr/>
+        <p:txBody>
+          <a:bodyPr/>
+          <a:lstStyle/>
+          <a:p>
+            <a:pPr lvl="0" indent="0" marL="0">
+              <a:buNone/>
+            </a:pPr>
+            <a:r>
+              <a:rPr/>
+              <a:t>Transport and logistics sector</a:t>
+            </a:r>
+          </a:p>
+        </p:txBody>
+      </p:sp>
+      <p:sp>
+        <p:nvSpPr>
+          <p:cNvPr id="3" name="Content Placeholder 2"/>
+          <p:cNvSpPr>
+            <a:spLocks noGrp="1"/>
+          </p:cNvSpPr>
+          <p:nvPr>
+            <p:ph idx="1"/>
+          </p:nvPr>
+        </p:nvSpPr>
+        <p:spPr/>
+        <p:txBody>
+          <a:bodyPr/>
+          <a:lstStyle/>
+          <a:p>
+            <a:pPr lvl="0"/>
+            <a:r>
+              <a:rPr/>
+              <a:t>Digital freight matching</a:t>
+            </a:r>
+          </a:p>
+          <a:p>
+            <a:pPr lvl="0"/>
+            <a:r>
+              <a:rPr/>
+              <a:t>Digital courier logistics</a:t>
+            </a:r>
+          </a:p>
+          <a:p>
+            <a:pPr lvl="0"/>
+            <a:r>
+              <a:rPr/>
+              <a:t>IoT-enabled cold chain</a:t>
+            </a:r>
+          </a:p>
+        </p:txBody>
+      </p:sp>
+    </p:spTree>
+  </p:cSld>
+</p:sld>
+</file>
+
+<file path=ppt/slides/slide25.xml><?xml version="1.0" encoding="utf-8"?>
+<p:sld xmlns:a="http://schemas.openxmlformats.org/drawingml/2006/main" xmlns:r="http://schemas.openxmlformats.org/officeDocument/2006/relationships" xmlns:p="http://schemas.openxmlformats.org/presentationml/2006/main">
+  <p:cSld>
+    <p:spTree>
+      <p:nvGrpSpPr>
+        <p:cNvPr id="1" name=""/>
+        <p:cNvGrpSpPr/>
+        <p:nvPr/>
+      </p:nvGrpSpPr>
+      <p:grpSpPr>
+        <a:xfrm>
+          <a:off x="0" y="0"/>
+          <a:ext cx="0" cy="0"/>
+          <a:chOff x="0" y="0"/>
+          <a:chExt cx="0" cy="0"/>
+        </a:xfrm>
+      </p:grpSpPr>
+      <p:sp>
+        <p:nvSpPr>
+          <p:cNvPr id="2" name="Title 1"/>
+          <p:cNvSpPr>
+            <a:spLocks noGrp="1"/>
+          </p:cNvSpPr>
+          <p:nvPr>
+            <p:ph type="title"/>
+          </p:nvPr>
+        </p:nvSpPr>
+        <p:spPr/>
+        <p:txBody>
+          <a:bodyPr/>
+          <a:lstStyle/>
+          <a:p>
+            <a:pPr lvl="0" indent="0" marL="0">
+              <a:buNone/>
+            </a:pPr>
+            <a:r>
+              <a:rPr/>
+              <a:t>Risks to market structure from platform firms</a:t>
+            </a:r>
+          </a:p>
+        </p:txBody>
+      </p:sp>
+      <p:pic>
+        <p:nvPicPr>
+          <p:cNvPr descr="../images/data_platform_risks.png" id="0" name="Picture 1"/>
+          <p:cNvPicPr>
+            <a:picLocks noGrp="1" noChangeAspect="1"/>
+          </p:cNvPicPr>
+          <p:nvPr/>
+        </p:nvPicPr>
+        <p:blipFill>
+          <a:blip r:embed="rId2"/>
+          <a:stretch>
+            <a:fillRect/>
+          </a:stretch>
+        </p:blipFill>
+        <p:spPr bwMode="auto">
+          <a:xfrm>
+            <a:off x="533400" y="1193800"/>
+            <a:ext cx="8089900" cy="3390900"/>
+          </a:xfrm>
+          <a:prstGeom prst="rect">
+            <a:avLst/>
+          </a:prstGeom>
+          <a:noFill/>
+          <a:ln w="9525">
+            <a:noFill/>
+            <a:headEnd/>
+            <a:tailEnd/>
+          </a:ln>
+        </p:spPr>
+      </p:pic>
+    </p:spTree>
+  </p:cSld>
+</p:sld>
+</file>
+
+<file path=ppt/slides/slide26.xml><?xml version="1.0" encoding="utf-8"?>
+<p:sld xmlns:a="http://schemas.openxmlformats.org/drawingml/2006/main" xmlns:r="http://schemas.openxmlformats.org/officeDocument/2006/relationships" xmlns:p="http://schemas.openxmlformats.org/presentationml/2006/main">
+  <p:cSld>
+    <p:spTree>
+      <p:nvGrpSpPr>
+        <p:cNvPr id="1" name=""/>
+        <p:cNvGrpSpPr/>
+        <p:nvPr/>
+      </p:nvGrpSpPr>
+      <p:grpSpPr>
+        <a:xfrm>
+          <a:off x="0" y="0"/>
+          <a:ext cx="0" cy="0"/>
+          <a:chOff x="0" y="0"/>
+          <a:chExt cx="0" cy="0"/>
+        </a:xfrm>
+      </p:grpSpPr>
+      <p:sp>
+        <p:nvSpPr>
+          <p:cNvPr id="2" name="Title 1"/>
+          <p:cNvSpPr>
+            <a:spLocks noGrp="1"/>
+          </p:cNvSpPr>
+          <p:nvPr>
+            <p:ph type="title"/>
+          </p:nvPr>
+        </p:nvSpPr>
+        <p:spPr/>
+        <p:txBody>
+          <a:bodyPr/>
+          <a:lstStyle/>
+          <a:p>
+            <a:pPr lvl="0" indent="0" marL="0">
+              <a:buNone/>
+            </a:pPr>
+            <a:r>
+              <a:rPr/>
+              <a:t>Risks and adverse outcomes of data-driven businesses</a:t>
+            </a:r>
+          </a:p>
+        </p:txBody>
+      </p:sp>
+      <p:sp>
+        <p:nvSpPr>
+          <p:cNvPr id="3" name="Content Placeholder 2"/>
+          <p:cNvSpPr>
+            <a:spLocks noGrp="1"/>
+          </p:cNvSpPr>
+          <p:nvPr>
+            <p:ph idx="1"/>
+          </p:nvPr>
+        </p:nvSpPr>
+        <p:spPr/>
+        <p:txBody>
+          <a:bodyPr/>
+          <a:lstStyle/>
+          <a:p>
+            <a:pPr lvl="0"/>
+            <a:r>
+              <a:rPr/>
+              <a:t>Increase propensity of dominant firms emerging</a:t>
+            </a:r>
+          </a:p>
+          <a:p>
+            <a:pPr lvl="0"/>
+            <a:r>
+              <a:rPr/>
+              <a:t>Potential for exploitation of individuals</a:t>
+            </a:r>
+          </a:p>
+          <a:p>
+            <a:pPr lvl="0"/>
+            <a:r>
+              <a:rPr/>
+              <a:t>Potential to increase inequality within and among countries</a:t>
+            </a:r>
+          </a:p>
+        </p:txBody>
+      </p:sp>
+    </p:spTree>
+  </p:cSld>
+</p:sld>
+</file>
+
+<file path=ppt/slides/slide3.xml><?xml version="1.0" encoding="utf-8"?>
+<p:sld xmlns:a="http://schemas.openxmlformats.org/drawingml/2006/main" xmlns:r="http://schemas.openxmlformats.org/officeDocument/2006/relationships" xmlns:p="http://schemas.openxmlformats.org/presentationml/2006/main">
+  <p:cSld>
+    <p:spTree>
+      <p:nvGrpSpPr>
+        <p:cNvPr id="1" name=""/>
+        <p:cNvGrpSpPr/>
+        <p:nvPr/>
+      </p:nvGrpSpPr>
+      <p:grpSpPr>
+        <a:xfrm>
+          <a:off x="0" y="0"/>
+          <a:ext cx="0" cy="0"/>
+          <a:chOff x="0" y="0"/>
+          <a:chExt cx="0" cy="0"/>
+        </a:xfrm>
+      </p:grpSpPr>
+      <p:sp>
+        <p:nvSpPr>
+          <p:cNvPr id="2" name="Title 1"/>
+          <p:cNvSpPr>
+            <a:spLocks noGrp="1"/>
+          </p:cNvSpPr>
+          <p:nvPr>
+            <p:ph type="title"/>
+          </p:nvPr>
+        </p:nvSpPr>
+        <p:spPr/>
+        <p:txBody>
+          <a:bodyPr/>
+          <a:lstStyle/>
+          <a:p>
+            <a:pPr lvl="0" indent="0" marL="0">
+              <a:buNone/>
+            </a:pPr>
+            <a:r>
+              <a:rPr/>
+              <a:t>Definitions</a:t>
+            </a:r>
+          </a:p>
+        </p:txBody>
+      </p:sp>
+    </p:spTree>
+  </p:cSld>
+</p:sld>
+</file>
+
+<file path=ppt/slides/slide4.xml><?xml version="1.0" encoding="utf-8"?>
+<p:sld xmlns:a="http://schemas.openxmlformats.org/drawingml/2006/main" xmlns:r="http://schemas.openxmlformats.org/officeDocument/2006/relationships" xmlns:p="http://schemas.openxmlformats.org/presentationml/2006/main">
+  <p:cSld>
+    <p:spTree>
+      <p:nvGrpSpPr>
+        <p:cNvPr id="1" name=""/>
+        <p:cNvGrpSpPr/>
+        <p:nvPr/>
+      </p:nvGrpSpPr>
+      <p:grpSpPr>
+        <a:xfrm>
+          <a:off x="0" y="0"/>
+          <a:ext cx="0" cy="0"/>
+          <a:chOff x="0" y="0"/>
+          <a:chExt cx="0" cy="0"/>
+        </a:xfrm>
+      </p:grpSpPr>
+      <p:sp>
+        <p:nvSpPr>
+          <p:cNvPr id="2" name="Title 1"/>
+          <p:cNvSpPr>
+            <a:spLocks noGrp="1"/>
+          </p:cNvSpPr>
+          <p:nvPr>
+            <p:ph type="title"/>
+          </p:nvPr>
+        </p:nvSpPr>
+        <p:spPr/>
+        <p:txBody>
+          <a:bodyPr/>
+          <a:lstStyle/>
+          <a:p>
+            <a:pPr lvl="0" indent="0" marL="0">
+              <a:buNone/>
+            </a:pPr>
+            <a:r>
+              <a:rPr/>
+              <a:t>What is data?</a:t>
+            </a:r>
+          </a:p>
+        </p:txBody>
+      </p:sp>
+      <p:sp>
+        <p:nvSpPr>
+          <p:cNvPr id="3" name="Content Placeholder 2"/>
+          <p:cNvSpPr>
+            <a:spLocks noGrp="1"/>
+          </p:cNvSpPr>
+          <p:nvPr>
+            <p:ph idx="1"/>
+          </p:nvPr>
+        </p:nvSpPr>
+        <p:spPr/>
+        <p:txBody>
+          <a:bodyPr/>
+          <a:lstStyle/>
+          <a:p>
+            <a:pPr lvl="0" indent="0" marL="0">
+              <a:buNone/>
+            </a:pPr>
+            <a:r>
+              <a:rPr/>
+              <a:t>“When we refer to data, we mean information about people, things and systems. … Data about people can include personal data, such as basic contact details, records generated through interaction with services or the web, or information about their physical characteristics (biometrics) - and it can also extend to population-level data, such as demographics. Data can also be about systems and infrastructure, such as administrative records about businesses and public services. Data is increasingly used to describe location, such as geospatial reference details, and the environment we live in, such as data about biodiversity or the weather. It can also refer to the information generated by the burgeoning web of sensors that make up the Internet of Things.”</a:t>
+            </a:r>
+          </a:p>
+          <a:p>
+            <a:pPr lvl="0" indent="0">
+              <a:buNone/>
+            </a:pPr>
+            <a:r>
+              <a:rPr>
+                <a:latin typeface="Courier"/>
+              </a:rPr>
+              <a:t>                                                 - UK National Data Strategy</a:t>
+            </a:r>
+          </a:p>
+        </p:txBody>
+      </p:sp>
+    </p:spTree>
+  </p:cSld>
+</p:sld>
+</file>
+
+<file path=ppt/slides/slide5.xml><?xml version="1.0" encoding="utf-8"?>
+<p:sld xmlns:a="http://schemas.openxmlformats.org/drawingml/2006/main" xmlns:r="http://schemas.openxmlformats.org/officeDocument/2006/relationships" xmlns:p="http://schemas.openxmlformats.org/presentationml/2006/main">
+  <p:cSld>
+    <p:spTree>
+      <p:nvGrpSpPr>
+        <p:cNvPr id="1" name=""/>
+        <p:cNvGrpSpPr/>
+        <p:nvPr/>
+      </p:nvGrpSpPr>
+      <p:grpSpPr>
+        <a:xfrm>
+          <a:off x="0" y="0"/>
+          <a:ext cx="0" cy="0"/>
+          <a:chOff x="0" y="0"/>
+          <a:chExt cx="0" cy="0"/>
+        </a:xfrm>
+      </p:grpSpPr>
+      <p:sp>
+        <p:nvSpPr>
+          <p:cNvPr id="2" name="Title 1"/>
+          <p:cNvSpPr>
+            <a:spLocks noGrp="1"/>
+          </p:cNvSpPr>
+          <p:nvPr>
+            <p:ph type="title"/>
+          </p:nvPr>
+        </p:nvSpPr>
+        <p:spPr/>
+        <p:txBody>
+          <a:bodyPr/>
+          <a:lstStyle/>
+          <a:p>
+            <a:pPr lvl="0" indent="0" marL="0">
+              <a:buNone/>
+            </a:pPr>
+            <a:r>
+              <a:rPr/>
+              <a:t>What is data governance?</a:t>
+            </a:r>
+          </a:p>
+        </p:txBody>
+      </p:sp>
+      <p:sp>
+        <p:nvSpPr>
+          <p:cNvPr id="3" name="Content Placeholder 2"/>
+          <p:cNvSpPr>
+            <a:spLocks noGrp="1"/>
+          </p:cNvSpPr>
+          <p:nvPr>
+            <p:ph idx="1" sz="half"/>
+          </p:nvPr>
+        </p:nvSpPr>
+        <p:spPr/>
+        <p:txBody>
+          <a:bodyPr/>
+          <a:lstStyle/>
+          <a:p>
+            <a:pPr lvl="0" indent="0" marL="0">
+              <a:buNone/>
+            </a:pPr>
+            <a:r>
+              <a:rPr/>
+              <a:t>A system of </a:t>
+            </a:r>
+            <a:r>
+              <a:rPr b="1"/>
+              <a:t>robust legal frameworks</a:t>
+            </a:r>
+            <a:r>
+              <a:rPr/>
+              <a:t>, </a:t>
+            </a:r>
+            <a:r>
+              <a:rPr b="1"/>
+              <a:t>ethical guidelines</a:t>
+            </a:r>
+            <a:r>
+              <a:rPr/>
+              <a:t>, </a:t>
+            </a:r>
+            <a:r>
+              <a:rPr b="1"/>
+              <a:t>standards</a:t>
+            </a:r>
+            <a:r>
+              <a:rPr/>
+              <a:t>, and </a:t>
+            </a:r>
+            <a:r>
+              <a:rPr b="1"/>
+              <a:t>processes</a:t>
+            </a:r>
+            <a:r>
+              <a:rPr/>
+              <a:t> that ensures an organisation’s data is </a:t>
+            </a:r>
+            <a:r>
+              <a:rPr b="1"/>
+              <a:t>accurate</a:t>
+            </a:r>
+            <a:r>
+              <a:rPr/>
+              <a:t>, </a:t>
+            </a:r>
+            <a:r>
+              <a:rPr b="1"/>
+              <a:t>consistent</a:t>
+            </a:r>
+            <a:r>
+              <a:rPr/>
+              <a:t>, </a:t>
+            </a:r>
+            <a:r>
+              <a:rPr b="1"/>
+              <a:t>secure</a:t>
+            </a:r>
+            <a:r>
+              <a:rPr/>
+              <a:t>, and </a:t>
+            </a:r>
+            <a:r>
+              <a:rPr b="1"/>
+              <a:t>compliant</a:t>
+            </a:r>
+            <a:r>
+              <a:rPr/>
+              <a:t> throughout its lifecycle.</a:t>
+            </a:r>
+          </a:p>
+        </p:txBody>
+      </p:sp>
+      <p:pic>
+        <p:nvPicPr>
+          <p:cNvPr descr="../images/data_governance_infographic.jpg" id="0" name="Picture 1"/>
+          <p:cNvPicPr>
+            <a:picLocks noGrp="1" noChangeAspect="1"/>
+          </p:cNvPicPr>
+          <p:nvPr/>
+        </p:nvPicPr>
+        <p:blipFill>
+          <a:blip r:embed="rId2"/>
+          <a:stretch>
+            <a:fillRect/>
+          </a:stretch>
+        </p:blipFill>
+        <p:spPr bwMode="auto">
+          <a:xfrm>
+            <a:off x="4648200" y="1866900"/>
+            <a:ext cx="4038600" cy="2044700"/>
+          </a:xfrm>
+          <a:prstGeom prst="rect">
+            <a:avLst/>
+          </a:prstGeom>
+          <a:noFill/>
+          <a:ln w="9525">
+            <a:noFill/>
+            <a:headEnd/>
+            <a:tailEnd/>
+          </a:ln>
+        </p:spPr>
+      </p:pic>
+    </p:spTree>
+  </p:cSld>
+</p:sld>
+</file>
+
+<file path=ppt/slides/slide6.xml><?xml version="1.0" encoding="utf-8"?>
+<p:sld xmlns:a="http://schemas.openxmlformats.org/drawingml/2006/main" xmlns:r="http://schemas.openxmlformats.org/officeDocument/2006/relationships" xmlns:p="http://schemas.openxmlformats.org/presentationml/2006/main">
+  <p:cSld>
+    <p:spTree>
+      <p:nvGrpSpPr>
+        <p:cNvPr id="1" name=""/>
+        <p:cNvGrpSpPr/>
+        <p:nvPr/>
+      </p:nvGrpSpPr>
+      <p:grpSpPr>
+        <a:xfrm>
+          <a:off x="0" y="0"/>
+          <a:ext cx="0" cy="0"/>
+          <a:chOff x="0" y="0"/>
+          <a:chExt cx="0" cy="0"/>
+        </a:xfrm>
+      </p:grpSpPr>
+      <p:sp>
+        <p:nvSpPr>
+          <p:cNvPr id="2" name="Title 1"/>
+          <p:cNvSpPr>
+            <a:spLocks noGrp="1"/>
+          </p:cNvSpPr>
+          <p:nvPr>
+            <p:ph type="title"/>
+          </p:nvPr>
+        </p:nvSpPr>
+        <p:spPr/>
+        <p:txBody>
+          <a:bodyPr/>
+          <a:lstStyle/>
+          <a:p>
+            <a:pPr lvl="0" indent="0" marL="0">
+              <a:buNone/>
+            </a:pPr>
+            <a:r>
+              <a:rPr/>
+              <a:t>Data lifecycle</a:t>
+            </a:r>
+          </a:p>
+        </p:txBody>
+      </p:sp>
+      <p:pic>
+        <p:nvPicPr>
+          <p:cNvPr descr="../images/data_lifecycle.png" id="0" name="Picture 1"/>
+          <p:cNvPicPr>
+            <a:picLocks noGrp="1" noChangeAspect="1"/>
+          </p:cNvPicPr>
+          <p:nvPr/>
+        </p:nvPicPr>
+        <p:blipFill>
+          <a:blip r:embed="rId2"/>
+          <a:stretch>
+            <a:fillRect/>
+          </a:stretch>
+        </p:blipFill>
+        <p:spPr bwMode="auto">
+          <a:xfrm>
+            <a:off x="2286000" y="1193800"/>
+            <a:ext cx="4572000" cy="3390900"/>
+          </a:xfrm>
+          <a:prstGeom prst="rect">
+            <a:avLst/>
+          </a:prstGeom>
+          <a:noFill/>
+          <a:ln w="9525">
+            <a:noFill/>
+            <a:headEnd/>
+            <a:tailEnd/>
+          </a:ln>
+        </p:spPr>
+      </p:pic>
+    </p:spTree>
+  </p:cSld>
+</p:sld>
+</file>
+
+<file path=ppt/slides/slide7.xml><?xml version="1.0" encoding="utf-8"?>
+<p:sld xmlns:a="http://schemas.openxmlformats.org/drawingml/2006/main" xmlns:r="http://schemas.openxmlformats.org/officeDocument/2006/relationships" xmlns:p="http://schemas.openxmlformats.org/presentationml/2006/main">
+  <p:cSld>
+    <p:spTree>
+      <p:nvGrpSpPr>
+        <p:cNvPr id="1" name=""/>
+        <p:cNvGrpSpPr/>
+        <p:nvPr/>
+      </p:nvGrpSpPr>
+      <p:grpSpPr>
+        <a:xfrm>
+          <a:off x="0" y="0"/>
+          <a:ext cx="0" cy="0"/>
+          <a:chOff x="0" y="0"/>
+          <a:chExt cx="0" cy="0"/>
+        </a:xfrm>
+      </p:grpSpPr>
+      <p:sp>
+        <p:nvSpPr>
+          <p:cNvPr id="3" name="Content Placeholder 2"/>
+          <p:cNvSpPr>
+            <a:spLocks noGrp="1"/>
+          </p:cNvSpPr>
+          <p:nvPr>
+            <p:ph idx="1" sz="half"/>
+          </p:nvPr>
+        </p:nvSpPr>
+        <p:spPr/>
+        <p:txBody>
+          <a:bodyPr/>
+          <a:lstStyle/>
+          <a:p>
+            <a:pPr lvl="0" indent="0" marL="0">
+              <a:spcBef>
+                <a:spcPts val="3000"/>
+              </a:spcBef>
+              <a:buNone/>
+            </a:pPr>
+            <a:r>
+              <a:rPr b="1"/>
+              <a:t>Public intent data</a:t>
+            </a:r>
+          </a:p>
+          <a:p>
+            <a:pPr lvl="0"/>
+            <a:r>
+              <a:rPr/>
+              <a:t>Public intent data is data collected for public purposes.</a:t>
+            </a:r>
+          </a:p>
+          <a:p>
+            <a:pPr lvl="0"/>
+            <a:r>
+              <a:rPr/>
+              <a:t>Public intent data is a foundation of public policies and can play a transformative role in the public sector.</a:t>
+            </a:r>
+          </a:p>
+        </p:txBody>
+      </p:sp>
+      <p:sp>
+        <p:nvSpPr>
+          <p:cNvPr id="4" name="Content Placeholder 3"/>
+          <p:cNvSpPr>
+            <a:spLocks noGrp="1"/>
+          </p:cNvSpPr>
+          <p:nvPr>
+            <p:ph idx="2" sz="half"/>
+          </p:nvPr>
+        </p:nvSpPr>
+        <p:spPr/>
+        <p:txBody>
+          <a:bodyPr/>
+          <a:lstStyle/>
+          <a:p>
+            <a:pPr lvl="0" indent="0" marL="0">
+              <a:spcBef>
+                <a:spcPts val="3000"/>
+              </a:spcBef>
+              <a:buNone/>
+            </a:pPr>
+            <a:r>
+              <a:rPr b="1"/>
+              <a:t>Private intent data</a:t>
+            </a:r>
+          </a:p>
+          <a:p>
+            <a:pPr lvl="0"/>
+            <a:r>
+              <a:rPr/>
+              <a:t>Private intent data is data collected by the private sector as part of routine business processes.</a:t>
+            </a:r>
+          </a:p>
+          <a:p>
+            <a:pPr lvl="0"/>
+            <a:r>
+              <a:rPr/>
+              <a:t>Private intent data can drive innovation, lower transaction costs, and improve productivity, competitiveness, and economic growth.</a:t>
+            </a:r>
+          </a:p>
+        </p:txBody>
+      </p:sp>
+    </p:spTree>
+  </p:cSld>
+</p:sld>
+</file>
+
+<file path=ppt/slides/slide8.xml><?xml version="1.0" encoding="utf-8"?>
+<p:sld xmlns:a="http://schemas.openxmlformats.org/drawingml/2006/main" xmlns:r="http://schemas.openxmlformats.org/officeDocument/2006/relationships" xmlns:p="http://schemas.openxmlformats.org/presentationml/2006/main">
+  <p:cSld>
+    <p:spTree>
+      <p:nvGrpSpPr>
+        <p:cNvPr id="1" name=""/>
+        <p:cNvGrpSpPr/>
+        <p:nvPr/>
+      </p:nvGrpSpPr>
+      <p:grpSpPr>
+        <a:xfrm>
+          <a:off x="0" y="0"/>
+          <a:ext cx="0" cy="0"/>
+          <a:chOff x="0" y="0"/>
+          <a:chExt cx="0" cy="0"/>
+        </a:xfrm>
+      </p:grpSpPr>
+      <p:sp>
+        <p:nvSpPr>
+          <p:cNvPr id="2" name="Title 1"/>
+          <p:cNvSpPr>
+            <a:spLocks noGrp="1"/>
+          </p:cNvSpPr>
+          <p:nvPr>
+            <p:ph type="title"/>
+          </p:nvPr>
+        </p:nvSpPr>
+        <p:spPr/>
+        <p:txBody>
+          <a:bodyPr/>
+          <a:lstStyle/>
+          <a:p>
+            <a:pPr lvl="0" indent="0" marL="0">
+              <a:buNone/>
+            </a:pPr>
+            <a:r>
+              <a:rPr/>
+              <a:t>Types of public intent data</a:t>
+            </a:r>
+          </a:p>
+        </p:txBody>
+      </p:sp>
+      <p:sp>
+        <p:nvSpPr>
+          <p:cNvPr id="3" name="Content Placeholder 2"/>
+          <p:cNvSpPr>
+            <a:spLocks noGrp="1"/>
+          </p:cNvSpPr>
+          <p:nvPr>
+            <p:ph idx="1"/>
+          </p:nvPr>
+        </p:nvSpPr>
+        <p:spPr/>
+        <p:txBody>
+          <a:bodyPr/>
+          <a:lstStyle/>
+          <a:p>
+            <a:pPr lvl="0"/>
+            <a:r>
+              <a:rPr/>
+              <a:t>Administrative data</a:t>
+            </a:r>
+          </a:p>
+          <a:p>
+            <a:pPr lvl="0"/>
+            <a:r>
+              <a:rPr/>
+              <a:t>Census data</a:t>
+            </a:r>
+          </a:p>
+          <a:p>
+            <a:pPr lvl="0"/>
+            <a:r>
+              <a:rPr/>
+              <a:t>Sample surveys</a:t>
+            </a:r>
+          </a:p>
+          <a:p>
+            <a:pPr lvl="0"/>
+            <a:r>
+              <a:rPr/>
+              <a:t>Citizen-generated data</a:t>
+            </a:r>
+          </a:p>
+          <a:p>
+            <a:pPr lvl="0"/>
+            <a:r>
+              <a:rPr/>
+              <a:t>Machine-generated data</a:t>
+            </a:r>
+          </a:p>
+          <a:p>
+            <a:pPr lvl="0"/>
+            <a:r>
+              <a:rPr/>
+              <a:t>Geospatial data</a:t>
+            </a:r>
+          </a:p>
+        </p:txBody>
+      </p:sp>
+    </p:spTree>
+  </p:cSld>
+</p:sld>
+</file>
+
+<file path=ppt/slides/slide9.xml><?xml version="1.0" encoding="utf-8"?>
+<p:sld xmlns:a="http://schemas.openxmlformats.org/drawingml/2006/main" xmlns:r="http://schemas.openxmlformats.org/officeDocument/2006/relationships" xmlns:p="http://schemas.openxmlformats.org/presentationml/2006/main">
+  <p:cSld>
+    <p:spTree>
+      <p:nvGrpSpPr>
+        <p:cNvPr id="1" name=""/>
+        <p:cNvGrpSpPr/>
+        <p:nvPr/>
+      </p:nvGrpSpPr>
+      <p:grpSpPr>
+        <a:xfrm>
+          <a:off x="0" y="0"/>
+          <a:ext cx="0" cy="0"/>
+          <a:chOff x="0" y="0"/>
+          <a:chExt cx="0" cy="0"/>
+        </a:xfrm>
+      </p:grpSpPr>
+      <p:sp>
+        <p:nvSpPr>
+          <p:cNvPr id="2" name="Title 1"/>
+          <p:cNvSpPr>
+            <a:spLocks noGrp="1"/>
+          </p:cNvSpPr>
+          <p:nvPr>
+            <p:ph type="title"/>
+          </p:nvPr>
+        </p:nvSpPr>
+        <p:spPr/>
+        <p:txBody>
+          <a:bodyPr/>
+          <a:lstStyle/>
+          <a:p>
+            <a:pPr lvl="0" indent="0" marL="0">
+              <a:buNone/>
+            </a:pPr>
+            <a:r>
+              <a:rPr/>
+              <a:t>Maximising value of public intent data</a:t>
+            </a:r>
+          </a:p>
+        </p:txBody>
+      </p:sp>
+      <p:pic>
+        <p:nvPicPr>
+          <p:cNvPr descr="../images/data_value_maximise.png" id="0" name="Picture 1"/>
+          <p:cNvPicPr>
+            <a:picLocks noGrp="1" noChangeAspect="1"/>
+          </p:cNvPicPr>
+          <p:nvPr/>
+        </p:nvPicPr>
+        <p:blipFill>
+          <a:blip r:embed="rId2"/>
+          <a:stretch>
+            <a:fillRect/>
+          </a:stretch>
+        </p:blipFill>
+        <p:spPr bwMode="auto">
+          <a:xfrm>
+            <a:off x="457200" y="2095500"/>
+            <a:ext cx="8229600" cy="1600200"/>
+          </a:xfrm>
+          <a:prstGeom prst="rect">
+            <a:avLst/>
+          </a:prstGeom>
+          <a:noFill/>
+          <a:ln w="9525">
+            <a:noFill/>
+            <a:headEnd/>
+            <a:tailEnd/>
+          </a:ln>
+        </p:spPr>
+      </p:pic>
     </p:spTree>
   </p:cSld>
 </p:sld>

</xml_diff>

<commit_message>
Deploying to gh-pages from @ tamanh-oxford/capacity-development@348ed1eaa9fb6285cc6ca854cdd859ed17873803 🚀
</commit_message>
<xml_diff>
--- a/data-frameworks/01-global-landscape.pptx
+++ b/data-frameworks/01-global-landscape.pptx
@@ -5,7 +5,7 @@
     <p:sldMasterId id="2147483648" r:id="rId1"/>
   </p:sldMasterIdLst>
   <p:notesMasterIdLst>
-    <p:notesMasterId r:id="rId28"/>
+    <p:notesMasterId r:id="rId27"/>
   </p:notesMasterIdLst>
   <p:sldIdLst>
     <p:sldId id="256" r:id="rId2"/>
@@ -33,7 +33,6 @@
     <p:sldId id="278" r:id="rId24"/>
     <p:sldId id="279" r:id="rId25"/>
     <p:sldId id="280" r:id="rId26"/>
-    <p:sldId id="281" r:id="rId27"/>
   </p:sldIdLst>
   <p:sldSz cx="9144000" cy="5143500" type="screen16x9"/>
   <p:notesSz cx="6858000" cy="9144000"/>
@@ -617,7 +616,7 @@
           <a:p>
             <a:fld id="{18BDFEC3-8487-43E8-A154-7C12CBC1FFF2}" type="slidenum">
               <a:rPr lang="en-US"/>
-              <a:t>15</a:t>
+              <a:t>14</a:t>
             </a:fld>
             <a:endParaRPr lang="en-US"/>
           </a:p>
@@ -3699,44 +3698,7 @@
             </a:pPr>
             <a:r>
               <a:rPr/>
-              <a:t>Three pathways for public intent data to add value</a:t>
-            </a:r>
-          </a:p>
-        </p:txBody>
-      </p:sp>
-      <p:sp>
-        <p:nvSpPr>
-          <p:cNvPr id="3" name="Content Placeholder 2"/>
-          <p:cNvSpPr>
-            <a:spLocks noGrp="1"/>
-          </p:cNvSpPr>
-          <p:nvPr>
-            <p:ph idx="1"/>
-          </p:nvPr>
-        </p:nvSpPr>
-        <p:spPr/>
-        <p:txBody>
-          <a:bodyPr/>
-          <a:lstStyle/>
-          <a:p>
-            <a:pPr lvl="0"/>
-            <a:r>
-              <a:rPr/>
-              <a:t>Improving service delivery</a:t>
-            </a:r>
-          </a:p>
-          <a:p>
-            <a:pPr lvl="0"/>
-            <a:r>
-              <a:rPr/>
-              <a:t>Prioritising scarce resources</a:t>
-            </a:r>
-          </a:p>
-          <a:p>
-            <a:pPr lvl="0"/>
-            <a:r>
-              <a:rPr/>
-              <a:t>Holding government accountable and empowering individuals</a:t>
+              <a:t>Gaps in public intent data</a:t>
             </a:r>
           </a:p>
         </p:txBody>
@@ -3747,53 +3709,6 @@
 </file>
 
 <file path=ppt/slides/slide11.xml><?xml version="1.0" encoding="utf-8"?>
-<p:sld xmlns:a="http://schemas.openxmlformats.org/drawingml/2006/main" xmlns:r="http://schemas.openxmlformats.org/officeDocument/2006/relationships" xmlns:p="http://schemas.openxmlformats.org/presentationml/2006/main">
-  <p:cSld>
-    <p:spTree>
-      <p:nvGrpSpPr>
-        <p:cNvPr id="1" name=""/>
-        <p:cNvGrpSpPr/>
-        <p:nvPr/>
-      </p:nvGrpSpPr>
-      <p:grpSpPr>
-        <a:xfrm>
-          <a:off x="0" y="0"/>
-          <a:ext cx="0" cy="0"/>
-          <a:chOff x="0" y="0"/>
-          <a:chExt cx="0" cy="0"/>
-        </a:xfrm>
-      </p:grpSpPr>
-      <p:sp>
-        <p:nvSpPr>
-          <p:cNvPr id="2" name="Title 1"/>
-          <p:cNvSpPr>
-            <a:spLocks noGrp="1"/>
-          </p:cNvSpPr>
-          <p:nvPr>
-            <p:ph type="title"/>
-          </p:nvPr>
-        </p:nvSpPr>
-        <p:spPr/>
-        <p:txBody>
-          <a:bodyPr/>
-          <a:lstStyle/>
-          <a:p>
-            <a:pPr lvl="0" indent="0" marL="0">
-              <a:buNone/>
-            </a:pPr>
-            <a:r>
-              <a:rPr/>
-              <a:t>Gaps in public intent data</a:t>
-            </a:r>
-          </a:p>
-        </p:txBody>
-      </p:sp>
-    </p:spTree>
-  </p:cSld>
-</p:sld>
-</file>
-
-<file path=ppt/slides/slide12.xml><?xml version="1.0" encoding="utf-8"?>
 <p:sld xmlns:a="http://schemas.openxmlformats.org/drawingml/2006/main" xmlns:r="http://schemas.openxmlformats.org/officeDocument/2006/relationships" xmlns:p="http://schemas.openxmlformats.org/presentationml/2006/main">
   <p:cSld>
     <p:spTree>
@@ -3924,7 +3839,7 @@
 </p:sld>
 </file>
 
-<file path=ppt/slides/slide13.xml><?xml version="1.0" encoding="utf-8"?>
+<file path=ppt/slides/slide12.xml><?xml version="1.0" encoding="utf-8"?>
 <p:sld xmlns:a="http://schemas.openxmlformats.org/drawingml/2006/main" xmlns:r="http://schemas.openxmlformats.org/officeDocument/2006/relationships" xmlns:p="http://schemas.openxmlformats.org/presentationml/2006/main">
   <p:cSld>
     <p:spTree>
@@ -4062,6 +3977,100 @@
 </p:sld>
 </file>
 
+<file path=ppt/slides/slide13.xml><?xml version="1.0" encoding="utf-8"?>
+<p:sld xmlns:a="http://schemas.openxmlformats.org/drawingml/2006/main" xmlns:r="http://schemas.openxmlformats.org/officeDocument/2006/relationships" xmlns:p="http://schemas.openxmlformats.org/presentationml/2006/main">
+  <p:cSld>
+    <p:spTree>
+      <p:nvGrpSpPr>
+        <p:cNvPr id="1" name=""/>
+        <p:cNvGrpSpPr/>
+        <p:nvPr/>
+      </p:nvGrpSpPr>
+      <p:grpSpPr>
+        <a:xfrm>
+          <a:off x="0" y="0"/>
+          <a:ext cx="0" cy="0"/>
+          <a:chOff x="0" y="0"/>
+          <a:chExt cx="0" cy="0"/>
+        </a:xfrm>
+      </p:grpSpPr>
+      <p:sp>
+        <p:nvSpPr>
+          <p:cNvPr id="2" name="Title 1"/>
+          <p:cNvSpPr>
+            <a:spLocks noGrp="1"/>
+          </p:cNvSpPr>
+          <p:nvPr>
+            <p:ph type="title"/>
+          </p:nvPr>
+        </p:nvSpPr>
+        <p:spPr/>
+        <p:txBody>
+          <a:bodyPr/>
+          <a:lstStyle/>
+          <a:p>
+            <a:pPr lvl="0" indent="0" marL="0">
+              <a:buNone/>
+            </a:pPr>
+            <a:r>
+              <a:rPr/>
+              <a:t>Data not easy to use</a:t>
+            </a:r>
+          </a:p>
+        </p:txBody>
+      </p:sp>
+      <p:sp>
+        <p:nvSpPr>
+          <p:cNvPr id="3" name="Content Placeholder 2"/>
+          <p:cNvSpPr>
+            <a:spLocks noGrp="1"/>
+          </p:cNvSpPr>
+          <p:nvPr>
+            <p:ph idx="1"/>
+          </p:nvPr>
+        </p:nvSpPr>
+        <p:spPr/>
+        <p:txBody>
+          <a:bodyPr/>
+          <a:lstStyle/>
+          <a:p>
+            <a:pPr lvl="0"/>
+            <a:r>
+              <a:rPr/>
+              <a:t>Lack of </a:t>
+            </a:r>
+            <a:r>
+              <a:rPr i="1"/>
+              <a:t>accessibility</a:t>
+            </a:r>
+            <a:r>
+              <a:rPr/>
+              <a:t>, </a:t>
+            </a:r>
+            <a:r>
+              <a:rPr i="1"/>
+              <a:t>understandability</a:t>
+            </a:r>
+            <a:r>
+              <a:rPr/>
+              <a:t>, and </a:t>
+            </a:r>
+            <a:r>
+              <a:rPr i="1"/>
+              <a:t>interoperability</a:t>
+            </a:r>
+            <a:r>
+              <a:rPr/>
+              <a:t>.</a:t>
+            </a:r>
+          </a:p>
+        </p:txBody>
+      </p:sp>
+    </p:spTree>
+  </p:cSld>
+</p:sld>
+</file>
+
 <file path=ppt/slides/slide14.xml><?xml version="1.0" encoding="utf-8"?>
 <p:sld xmlns:a="http://schemas.openxmlformats.org/drawingml/2006/main" xmlns:r="http://schemas.openxmlformats.org/officeDocument/2006/relationships" xmlns:p="http://schemas.openxmlformats.org/presentationml/2006/main">
   <p:cSld>
@@ -4099,7 +4108,7 @@
             </a:pPr>
             <a:r>
               <a:rPr/>
-              <a:t>Data not easy to use</a:t>
+              <a:t>Data not safe to use</a:t>
             </a:r>
           </a:p>
         </p:txBody>
@@ -4122,31 +4131,21 @@
             <a:pPr lvl="0"/>
             <a:r>
               <a:rPr/>
-              <a:t>Lack of </a:t>
-            </a:r>
-            <a:r>
-              <a:rPr i="1"/>
-              <a:t>accessibility</a:t>
-            </a:r>
-            <a:r>
-              <a:rPr/>
-              <a:t>, </a:t>
-            </a:r>
-            <a:r>
-              <a:rPr i="1"/>
-              <a:t>understandability</a:t>
-            </a:r>
-            <a:r>
-              <a:rPr/>
-              <a:t>, and </a:t>
-            </a:r>
-            <a:r>
-              <a:rPr i="1"/>
-              <a:t>interoperability</a:t>
-            </a:r>
-            <a:r>
-              <a:rPr/>
-              <a:t>.</a:t>
+              <a:t>Data not immune to influence from stakeholders</a:t>
+            </a:r>
+          </a:p>
+          <a:p>
+            <a:pPr lvl="0"/>
+            <a:r>
+              <a:rPr/>
+              <a:t>Data not stored securely - too common in government and private sector databases</a:t>
+            </a:r>
+          </a:p>
+          <a:p>
+            <a:pPr lvl="0"/>
+            <a:r>
+              <a:rPr/>
+              <a:t>Data not properly de-identified</a:t>
             </a:r>
           </a:p>
         </p:txBody>
@@ -4193,7 +4192,7 @@
             </a:pPr>
             <a:r>
               <a:rPr/>
-              <a:t>Data not safe to use</a:t>
+              <a:t>Why gaps persist</a:t>
             </a:r>
           </a:p>
         </p:txBody>
@@ -4216,21 +4215,28 @@
             <a:pPr lvl="0"/>
             <a:r>
               <a:rPr/>
-              <a:t>Data not immune to influence from stakeholders</a:t>
-            </a:r>
-          </a:p>
-          <a:p>
-            <a:pPr lvl="0"/>
-            <a:r>
-              <a:rPr/>
-              <a:t>Data not stored securely - too common in government and private sector databases</a:t>
-            </a:r>
-          </a:p>
-          <a:p>
-            <a:pPr lvl="0"/>
-            <a:r>
-              <a:rPr/>
-              <a:t>Data not properly de-identified</a:t>
+              <a:t>Deficiencies in financing</a:t>
+            </a:r>
+          </a:p>
+          <a:p>
+            <a:pPr lvl="0"/>
+            <a:r>
+              <a:rPr/>
+              <a:t>Deficiencies in technical capacity</a:t>
+            </a:r>
+          </a:p>
+          <a:p>
+            <a:pPr lvl="0"/>
+            <a:r>
+              <a:rPr/>
+              <a:t>Deficiencies in governance</a:t>
+            </a:r>
+          </a:p>
+          <a:p>
+            <a:pPr lvl="0"/>
+            <a:r>
+              <a:rPr/>
+              <a:t>Deficiencies in data demand</a:t>
             </a:r>
           </a:p>
         </p:txBody>
@@ -4241,97 +4247,6 @@
 </file>
 
 <file path=ppt/slides/slide16.xml><?xml version="1.0" encoding="utf-8"?>
-<p:sld xmlns:a="http://schemas.openxmlformats.org/drawingml/2006/main" xmlns:r="http://schemas.openxmlformats.org/officeDocument/2006/relationships" xmlns:p="http://schemas.openxmlformats.org/presentationml/2006/main">
-  <p:cSld>
-    <p:spTree>
-      <p:nvGrpSpPr>
-        <p:cNvPr id="1" name=""/>
-        <p:cNvGrpSpPr/>
-        <p:nvPr/>
-      </p:nvGrpSpPr>
-      <p:grpSpPr>
-        <a:xfrm>
-          <a:off x="0" y="0"/>
-          <a:ext cx="0" cy="0"/>
-          <a:chOff x="0" y="0"/>
-          <a:chExt cx="0" cy="0"/>
-        </a:xfrm>
-      </p:grpSpPr>
-      <p:sp>
-        <p:nvSpPr>
-          <p:cNvPr id="2" name="Title 1"/>
-          <p:cNvSpPr>
-            <a:spLocks noGrp="1"/>
-          </p:cNvSpPr>
-          <p:nvPr>
-            <p:ph type="title"/>
-          </p:nvPr>
-        </p:nvSpPr>
-        <p:spPr/>
-        <p:txBody>
-          <a:bodyPr/>
-          <a:lstStyle/>
-          <a:p>
-            <a:pPr lvl="0" indent="0" marL="0">
-              <a:buNone/>
-            </a:pPr>
-            <a:r>
-              <a:rPr/>
-              <a:t>Why gaps persist</a:t>
-            </a:r>
-          </a:p>
-        </p:txBody>
-      </p:sp>
-      <p:sp>
-        <p:nvSpPr>
-          <p:cNvPr id="3" name="Content Placeholder 2"/>
-          <p:cNvSpPr>
-            <a:spLocks noGrp="1"/>
-          </p:cNvSpPr>
-          <p:nvPr>
-            <p:ph idx="1"/>
-          </p:nvPr>
-        </p:nvSpPr>
-        <p:spPr/>
-        <p:txBody>
-          <a:bodyPr/>
-          <a:lstStyle/>
-          <a:p>
-            <a:pPr lvl="0"/>
-            <a:r>
-              <a:rPr/>
-              <a:t>Deficiencies in financing</a:t>
-            </a:r>
-          </a:p>
-          <a:p>
-            <a:pPr lvl="0"/>
-            <a:r>
-              <a:rPr/>
-              <a:t>Deficiencies in technical capacity</a:t>
-            </a:r>
-          </a:p>
-          <a:p>
-            <a:pPr lvl="0"/>
-            <a:r>
-              <a:rPr/>
-              <a:t>Deficiencies in governance</a:t>
-            </a:r>
-          </a:p>
-          <a:p>
-            <a:pPr lvl="0"/>
-            <a:r>
-              <a:rPr/>
-              <a:t>Deficiencies in data demand</a:t>
-            </a:r>
-          </a:p>
-        </p:txBody>
-      </p:sp>
-    </p:spTree>
-  </p:cSld>
-</p:sld>
-</file>
-
-<file path=ppt/slides/slide17.xml><?xml version="1.0" encoding="utf-8"?>
 <p:sld xmlns:a="http://schemas.openxmlformats.org/drawingml/2006/main" xmlns:r="http://schemas.openxmlformats.org/officeDocument/2006/relationships" xmlns:p="http://schemas.openxmlformats.org/presentationml/2006/main">
   <p:cSld>
     <p:spTree>
@@ -4408,7 +4323,7 @@
 </p:sld>
 </file>
 
-<file path=ppt/slides/slide18.xml><?xml version="1.0" encoding="utf-8"?>
+<file path=ppt/slides/slide17.xml><?xml version="1.0" encoding="utf-8"?>
 <p:sld xmlns:a="http://schemas.openxmlformats.org/drawingml/2006/main" xmlns:r="http://schemas.openxmlformats.org/officeDocument/2006/relationships" xmlns:p="http://schemas.openxmlformats.org/presentationml/2006/main">
   <p:cSld>
     <p:spTree>
@@ -4485,6 +4400,87 @@
 </p:sld>
 </file>
 
+<file path=ppt/slides/slide18.xml><?xml version="1.0" encoding="utf-8"?>
+<p:sld xmlns:a="http://schemas.openxmlformats.org/drawingml/2006/main" xmlns:r="http://schemas.openxmlformats.org/officeDocument/2006/relationships" xmlns:p="http://schemas.openxmlformats.org/presentationml/2006/main">
+  <p:cSld>
+    <p:spTree>
+      <p:nvGrpSpPr>
+        <p:cNvPr id="1" name=""/>
+        <p:cNvGrpSpPr/>
+        <p:nvPr/>
+      </p:nvGrpSpPr>
+      <p:grpSpPr>
+        <a:xfrm>
+          <a:off x="0" y="0"/>
+          <a:ext cx="0" cy="0"/>
+          <a:chOff x="0" y="0"/>
+          <a:chExt cx="0" cy="0"/>
+        </a:xfrm>
+      </p:grpSpPr>
+      <p:sp>
+        <p:nvSpPr>
+          <p:cNvPr id="2" name="Title 1"/>
+          <p:cNvSpPr>
+            <a:spLocks noGrp="1"/>
+          </p:cNvSpPr>
+          <p:nvPr>
+            <p:ph type="title"/>
+          </p:nvPr>
+        </p:nvSpPr>
+        <p:spPr/>
+        <p:txBody>
+          <a:bodyPr/>
+          <a:lstStyle/>
+          <a:p>
+            <a:pPr lvl="0" indent="0" marL="0">
+              <a:buNone/>
+            </a:pPr>
+            <a:r>
+              <a:rPr/>
+              <a:t>Data inputs for economic activity</a:t>
+            </a:r>
+          </a:p>
+        </p:txBody>
+      </p:sp>
+      <p:sp>
+        <p:nvSpPr>
+          <p:cNvPr id="3" name="Content Placeholder 2"/>
+          <p:cNvSpPr>
+            <a:spLocks noGrp="1"/>
+          </p:cNvSpPr>
+          <p:nvPr>
+            <p:ph idx="1"/>
+          </p:nvPr>
+        </p:nvSpPr>
+        <p:spPr/>
+        <p:txBody>
+          <a:bodyPr/>
+          <a:lstStyle/>
+          <a:p>
+            <a:pPr lvl="0"/>
+            <a:r>
+              <a:rPr/>
+              <a:t>Data collection by firms - </a:t>
+            </a:r>
+            <a:r>
+              <a:rPr b="1"/>
+              <a:t>“digital footprint”</a:t>
+            </a:r>
+          </a:p>
+          <a:p>
+            <a:pPr lvl="0"/>
+            <a:r>
+              <a:rPr/>
+              <a:t>Use of public intent data by businesses</a:t>
+            </a:r>
+          </a:p>
+        </p:txBody>
+      </p:sp>
+    </p:spTree>
+  </p:cSld>
+</p:sld>
+</file>
+
 <file path=ppt/slides/slide19.xml><?xml version="1.0" encoding="utf-8"?>
 <p:sld xmlns:a="http://schemas.openxmlformats.org/drawingml/2006/main" xmlns:r="http://schemas.openxmlformats.org/officeDocument/2006/relationships" xmlns:p="http://schemas.openxmlformats.org/presentationml/2006/main">
   <p:cSld>
@@ -4522,7 +4518,7 @@
             </a:pPr>
             <a:r>
               <a:rPr/>
-              <a:t>Data inputs for economic activity</a:t>
+              <a:t>Sectors transformed by use of data in the production process</a:t>
             </a:r>
           </a:p>
         </p:txBody>
@@ -4545,18 +4541,35 @@
             <a:pPr lvl="0"/>
             <a:r>
               <a:rPr/>
-              <a:t>Data collection by firms - </a:t>
-            </a:r>
-            <a:r>
-              <a:rPr b="1"/>
-              <a:t>“digital footprint”</a:t>
-            </a:r>
-          </a:p>
-          <a:p>
-            <a:pPr lvl="0"/>
-            <a:r>
-              <a:rPr/>
-              <a:t>Use of public intent data by businesses</a:t>
+              <a:t>Finance</a:t>
+            </a:r>
+          </a:p>
+          <a:p>
+            <a:pPr lvl="0"/>
+            <a:r>
+              <a:rPr/>
+              <a:t>Agriculture</a:t>
+            </a:r>
+          </a:p>
+          <a:p>
+            <a:pPr lvl="0"/>
+            <a:r>
+              <a:rPr/>
+              <a:t>Health</a:t>
+            </a:r>
+          </a:p>
+          <a:p>
+            <a:pPr lvl="0"/>
+            <a:r>
+              <a:rPr/>
+              <a:t>Education</a:t>
+            </a:r>
+          </a:p>
+          <a:p>
+            <a:pPr lvl="0"/>
+            <a:r>
+              <a:rPr/>
+              <a:t>Transport and logistics</a:t>
             </a:r>
           </a:p>
         </p:txBody>
@@ -4603,29 +4616,6 @@
             </a:pPr>
             <a:r>
               <a:rPr/>
-              <a:t>Outline</a:t>
-            </a:r>
-          </a:p>
-        </p:txBody>
-      </p:sp>
-      <p:sp>
-        <p:nvSpPr>
-          <p:cNvPr id="3" name="Content Placeholder 2"/>
-          <p:cNvSpPr>
-            <a:spLocks noGrp="1"/>
-          </p:cNvSpPr>
-          <p:nvPr>
-            <p:ph idx="1"/>
-          </p:nvPr>
-        </p:nvSpPr>
-        <p:spPr/>
-        <p:txBody>
-          <a:bodyPr/>
-          <a:lstStyle/>
-          <a:p>
-            <a:pPr lvl="0"/>
-            <a:r>
-              <a:rPr/>
               <a:t>Definitions</a:t>
             </a:r>
           </a:p>
@@ -4673,7 +4663,7 @@
             </a:pPr>
             <a:r>
               <a:rPr/>
-              <a:t>Sectors transformed by use of data in the production process</a:t>
+              <a:t>Finance sector</a:t>
             </a:r>
           </a:p>
         </p:txBody>
@@ -4695,36 +4685,45 @@
           <a:p>
             <a:pPr lvl="0"/>
             <a:r>
-              <a:rPr/>
-              <a:t>Finance</a:t>
-            </a:r>
-          </a:p>
-          <a:p>
-            <a:pPr lvl="0"/>
-            <a:r>
-              <a:rPr/>
-              <a:t>Agriculture</a:t>
-            </a:r>
-          </a:p>
-          <a:p>
-            <a:pPr lvl="0"/>
-            <a:r>
-              <a:rPr/>
-              <a:t>Health</a:t>
-            </a:r>
-          </a:p>
-          <a:p>
-            <a:pPr lvl="0"/>
-            <a:r>
-              <a:rPr/>
-              <a:t>Education</a:t>
-            </a:r>
-          </a:p>
-          <a:p>
-            <a:pPr lvl="0"/>
-            <a:r>
-              <a:rPr/>
-              <a:t>Transport and logistics</a:t>
+              <a:rPr b="1"/>
+              <a:t>Alternative credit scoring algorithms</a:t>
+            </a:r>
+            <a:r>
+              <a:rPr/>
+              <a:t> - use of an individual’s digital footprint to train machine learning algorithms to identify, score, and underwrite credit.</a:t>
+            </a:r>
+          </a:p>
+          <a:p>
+            <a:pPr lvl="0"/>
+            <a:r>
+              <a:rPr b="1"/>
+              <a:t>Payment systems</a:t>
+            </a:r>
+            <a:r>
+              <a:rPr/>
+              <a:t> - digital payments; mobile payments.</a:t>
+            </a:r>
+          </a:p>
+          <a:p>
+            <a:pPr lvl="0"/>
+            <a:r>
+              <a:rPr b="1"/>
+              <a:t>Use of transaction data for product development</a:t>
+            </a:r>
+            <a:r>
+              <a:rPr/>
+              <a:t> - Mastercard’s Tourism Insights service allows leveraging big data to provide information on travellers’ preferences.</a:t>
+            </a:r>
+          </a:p>
+          <a:p>
+            <a:pPr lvl="0"/>
+            <a:r>
+              <a:rPr b="1"/>
+              <a:t>Distributed ledger technology</a:t>
+            </a:r>
+            <a:r>
+              <a:rPr/>
+              <a:t> - blockchain; eliminates financial intermediaries; embedding rules into smart contracts simplifies negotiation and verification processes.</a:t>
             </a:r>
           </a:p>
         </p:txBody>
@@ -4771,7 +4770,7 @@
             </a:pPr>
             <a:r>
               <a:rPr/>
-              <a:t>Finance sector</a:t>
+              <a:t>Agriculture sector</a:t>
             </a:r>
           </a:p>
         </p:txBody>
@@ -4793,45 +4792,29 @@
           <a:p>
             <a:pPr lvl="0"/>
             <a:r>
-              <a:rPr b="1"/>
-              <a:t>Alternative credit scoring algorithms</a:t>
-            </a:r>
-            <a:r>
-              <a:rPr/>
-              <a:t> - use of an individual’s digital footprint to train machine learning algorithms to identify, score, and underwrite credit.</a:t>
-            </a:r>
-          </a:p>
-          <a:p>
-            <a:pPr lvl="0"/>
-            <a:r>
-              <a:rPr b="1"/>
-              <a:t>Payment systems</a:t>
-            </a:r>
-            <a:r>
-              <a:rPr/>
-              <a:t> - digital payments; mobile payments.</a:t>
-            </a:r>
-          </a:p>
-          <a:p>
-            <a:pPr lvl="0"/>
-            <a:r>
-              <a:rPr b="1"/>
-              <a:t>Use of transaction data for product development</a:t>
-            </a:r>
-            <a:r>
-              <a:rPr/>
-              <a:t> - Mastercard’s Tourism Insights service allows leveraging big data to provide information on travellers’ preferences.</a:t>
-            </a:r>
-          </a:p>
-          <a:p>
-            <a:pPr lvl="0"/>
-            <a:r>
-              <a:rPr b="1"/>
-              <a:t>Distributed ledger technology</a:t>
-            </a:r>
-            <a:r>
-              <a:rPr/>
-              <a:t> - blockchain; eliminates financial intermediaries; embedding rules into smart contracts simplifies negotiation and verification processes.</a:t>
+              <a:rPr/>
+              <a:t>Remote sensing and geographic information systems - analysis of these data provide insights into farming operations; smart farming</a:t>
+            </a:r>
+          </a:p>
+          <a:p>
+            <a:pPr lvl="0"/>
+            <a:r>
+              <a:rPr/>
+              <a:t>Internet-of-things (IoT) and embedded devices for monitoring farm and livestock conditions and farm operations</a:t>
+            </a:r>
+          </a:p>
+          <a:p>
+            <a:pPr lvl="0"/>
+            <a:r>
+              <a:rPr/>
+              <a:t>Use of data to provide a range of services along the agriculture value chain</a:t>
+            </a:r>
+          </a:p>
+          <a:p>
+            <a:pPr lvl="0"/>
+            <a:r>
+              <a:rPr/>
+              <a:t>Use of data to improve food traceability</a:t>
             </a:r>
           </a:p>
         </p:txBody>
@@ -4878,7 +4861,7 @@
             </a:pPr>
             <a:r>
               <a:rPr/>
-              <a:t>Agriculture sector</a:t>
+              <a:t>Education</a:t>
             </a:r>
           </a:p>
         </p:txBody>
@@ -4901,28 +4884,21 @@
             <a:pPr lvl="0"/>
             <a:r>
               <a:rPr/>
-              <a:t>Remote sensing and geographic information systems - analysis of these data provide insights into farming operations; smart farming</a:t>
-            </a:r>
-          </a:p>
-          <a:p>
-            <a:pPr lvl="0"/>
-            <a:r>
-              <a:rPr/>
-              <a:t>Internet-of-things (IoT) and embedded devices for monitoring farm and livestock conditions and farm operations</a:t>
-            </a:r>
-          </a:p>
-          <a:p>
-            <a:pPr lvl="0"/>
-            <a:r>
-              <a:rPr/>
-              <a:t>Use of data to provide a range of services along the agriculture value chain</a:t>
-            </a:r>
-          </a:p>
-          <a:p>
-            <a:pPr lvl="0"/>
-            <a:r>
-              <a:rPr/>
-              <a:t>Use of data to improve food traceability</a:t>
+              <a:t>video conferencing/video communication tools</a:t>
+            </a:r>
+          </a:p>
+          <a:p>
+            <a:pPr lvl="0"/>
+            <a:r>
+              <a:rPr/>
+              <a:t>digital supplemental learning platforms</a:t>
+            </a:r>
+          </a:p>
+          <a:p>
+            <a:pPr lvl="0"/>
+            <a:r>
+              <a:rPr/>
+              <a:t>intelligent adaptive education</a:t>
             </a:r>
           </a:p>
         </p:txBody>
@@ -4969,7 +4945,7 @@
             </a:pPr>
             <a:r>
               <a:rPr/>
-              <a:t>Education</a:t>
+              <a:t>Transport and logistics sector</a:t>
             </a:r>
           </a:p>
         </p:txBody>
@@ -4992,21 +4968,21 @@
             <a:pPr lvl="0"/>
             <a:r>
               <a:rPr/>
-              <a:t>video conferencing/video communication tools</a:t>
-            </a:r>
-          </a:p>
-          <a:p>
-            <a:pPr lvl="0"/>
-            <a:r>
-              <a:rPr/>
-              <a:t>digital supplemental learning platforms</a:t>
-            </a:r>
-          </a:p>
-          <a:p>
-            <a:pPr lvl="0"/>
-            <a:r>
-              <a:rPr/>
-              <a:t>intelligent adaptive education</a:t>
+              <a:t>Digital freight matching</a:t>
+            </a:r>
+          </a:p>
+          <a:p>
+            <a:pPr lvl="0"/>
+            <a:r>
+              <a:rPr/>
+              <a:t>Digital courier logistics</a:t>
+            </a:r>
+          </a:p>
+          <a:p>
+            <a:pPr lvl="0"/>
+            <a:r>
+              <a:rPr/>
+              <a:t>IoT-enabled cold chain</a:t>
             </a:r>
           </a:p>
         </p:txBody>
@@ -5017,90 +4993,6 @@
 </file>
 
 <file path=ppt/slides/slide24.xml><?xml version="1.0" encoding="utf-8"?>
-<p:sld xmlns:a="http://schemas.openxmlformats.org/drawingml/2006/main" xmlns:r="http://schemas.openxmlformats.org/officeDocument/2006/relationships" xmlns:p="http://schemas.openxmlformats.org/presentationml/2006/main">
-  <p:cSld>
-    <p:spTree>
-      <p:nvGrpSpPr>
-        <p:cNvPr id="1" name=""/>
-        <p:cNvGrpSpPr/>
-        <p:nvPr/>
-      </p:nvGrpSpPr>
-      <p:grpSpPr>
-        <a:xfrm>
-          <a:off x="0" y="0"/>
-          <a:ext cx="0" cy="0"/>
-          <a:chOff x="0" y="0"/>
-          <a:chExt cx="0" cy="0"/>
-        </a:xfrm>
-      </p:grpSpPr>
-      <p:sp>
-        <p:nvSpPr>
-          <p:cNvPr id="2" name="Title 1"/>
-          <p:cNvSpPr>
-            <a:spLocks noGrp="1"/>
-          </p:cNvSpPr>
-          <p:nvPr>
-            <p:ph type="title"/>
-          </p:nvPr>
-        </p:nvSpPr>
-        <p:spPr/>
-        <p:txBody>
-          <a:bodyPr/>
-          <a:lstStyle/>
-          <a:p>
-            <a:pPr lvl="0" indent="0" marL="0">
-              <a:buNone/>
-            </a:pPr>
-            <a:r>
-              <a:rPr/>
-              <a:t>Transport and logistics sector</a:t>
-            </a:r>
-          </a:p>
-        </p:txBody>
-      </p:sp>
-      <p:sp>
-        <p:nvSpPr>
-          <p:cNvPr id="3" name="Content Placeholder 2"/>
-          <p:cNvSpPr>
-            <a:spLocks noGrp="1"/>
-          </p:cNvSpPr>
-          <p:nvPr>
-            <p:ph idx="1"/>
-          </p:nvPr>
-        </p:nvSpPr>
-        <p:spPr/>
-        <p:txBody>
-          <a:bodyPr/>
-          <a:lstStyle/>
-          <a:p>
-            <a:pPr lvl="0"/>
-            <a:r>
-              <a:rPr/>
-              <a:t>Digital freight matching</a:t>
-            </a:r>
-          </a:p>
-          <a:p>
-            <a:pPr lvl="0"/>
-            <a:r>
-              <a:rPr/>
-              <a:t>Digital courier logistics</a:t>
-            </a:r>
-          </a:p>
-          <a:p>
-            <a:pPr lvl="0"/>
-            <a:r>
-              <a:rPr/>
-              <a:t>IoT-enabled cold chain</a:t>
-            </a:r>
-          </a:p>
-        </p:txBody>
-      </p:sp>
-    </p:spTree>
-  </p:cSld>
-</p:sld>
-</file>
-
-<file path=ppt/slides/slide25.xml><?xml version="1.0" encoding="utf-8"?>
 <p:sld xmlns:a="http://schemas.openxmlformats.org/drawingml/2006/main" xmlns:r="http://schemas.openxmlformats.org/officeDocument/2006/relationships" xmlns:p="http://schemas.openxmlformats.org/presentationml/2006/main">
   <p:cSld>
     <p:spTree>
@@ -5177,7 +5069,7 @@
 </p:sld>
 </file>
 
-<file path=ppt/slides/slide26.xml><?xml version="1.0" encoding="utf-8"?>
+<file path=ppt/slides/slide25.xml><?xml version="1.0" encoding="utf-8"?>
 <p:sld xmlns:a="http://schemas.openxmlformats.org/drawingml/2006/main" xmlns:r="http://schemas.openxmlformats.org/officeDocument/2006/relationships" xmlns:p="http://schemas.openxmlformats.org/presentationml/2006/main">
   <p:cSld>
     <p:spTree>
@@ -5298,7 +5190,43 @@
             </a:pPr>
             <a:r>
               <a:rPr/>
-              <a:t>Definitions</a:t>
+              <a:t>What is data?</a:t>
+            </a:r>
+          </a:p>
+        </p:txBody>
+      </p:sp>
+      <p:sp>
+        <p:nvSpPr>
+          <p:cNvPr id="3" name="Content Placeholder 2"/>
+          <p:cNvSpPr>
+            <a:spLocks noGrp="1"/>
+          </p:cNvSpPr>
+          <p:nvPr>
+            <p:ph idx="1"/>
+          </p:nvPr>
+        </p:nvSpPr>
+        <p:spPr/>
+        <p:txBody>
+          <a:bodyPr/>
+          <a:lstStyle/>
+          <a:p>
+            <a:pPr lvl="0" indent="0" marL="0">
+              <a:buNone/>
+            </a:pPr>
+            <a:r>
+              <a:rPr/>
+              <a:t>“When we refer to data, we mean information about people, things and systems. … Data about people can include personal data, such as basic contact details, records generated through interaction with services or the web, or information about their physical characteristics (biometrics) - and it can also extend to population-level data, such as demographics. Data can also be about systems and infrastructure, such as administrative records about businesses and public services. Data is increasingly used to describe location, such as geospatial reference details, and the environment we live in, such as data about biodiversity or the weather. It can also refer to the information generated by the burgeoning web of sensors that make up the Internet of Things.”</a:t>
+            </a:r>
+          </a:p>
+          <a:p>
+            <a:pPr lvl="0" indent="0">
+              <a:buNone/>
+            </a:pPr>
+            <a:r>
+              <a:rPr>
+                <a:latin typeface="Courier"/>
+              </a:rPr>
+              <a:t>                                                 - UK National Data Strategy</a:t>
             </a:r>
           </a:p>
         </p:txBody>
@@ -5309,89 +5237,6 @@
 </file>
 
 <file path=ppt/slides/slide4.xml><?xml version="1.0" encoding="utf-8"?>
-<p:sld xmlns:a="http://schemas.openxmlformats.org/drawingml/2006/main" xmlns:r="http://schemas.openxmlformats.org/officeDocument/2006/relationships" xmlns:p="http://schemas.openxmlformats.org/presentationml/2006/main">
-  <p:cSld>
-    <p:spTree>
-      <p:nvGrpSpPr>
-        <p:cNvPr id="1" name=""/>
-        <p:cNvGrpSpPr/>
-        <p:nvPr/>
-      </p:nvGrpSpPr>
-      <p:grpSpPr>
-        <a:xfrm>
-          <a:off x="0" y="0"/>
-          <a:ext cx="0" cy="0"/>
-          <a:chOff x="0" y="0"/>
-          <a:chExt cx="0" cy="0"/>
-        </a:xfrm>
-      </p:grpSpPr>
-      <p:sp>
-        <p:nvSpPr>
-          <p:cNvPr id="2" name="Title 1"/>
-          <p:cNvSpPr>
-            <a:spLocks noGrp="1"/>
-          </p:cNvSpPr>
-          <p:nvPr>
-            <p:ph type="title"/>
-          </p:nvPr>
-        </p:nvSpPr>
-        <p:spPr/>
-        <p:txBody>
-          <a:bodyPr/>
-          <a:lstStyle/>
-          <a:p>
-            <a:pPr lvl="0" indent="0" marL="0">
-              <a:buNone/>
-            </a:pPr>
-            <a:r>
-              <a:rPr/>
-              <a:t>What is data?</a:t>
-            </a:r>
-          </a:p>
-        </p:txBody>
-      </p:sp>
-      <p:sp>
-        <p:nvSpPr>
-          <p:cNvPr id="3" name="Content Placeholder 2"/>
-          <p:cNvSpPr>
-            <a:spLocks noGrp="1"/>
-          </p:cNvSpPr>
-          <p:nvPr>
-            <p:ph idx="1"/>
-          </p:nvPr>
-        </p:nvSpPr>
-        <p:spPr/>
-        <p:txBody>
-          <a:bodyPr/>
-          <a:lstStyle/>
-          <a:p>
-            <a:pPr lvl="0" indent="0" marL="0">
-              <a:buNone/>
-            </a:pPr>
-            <a:r>
-              <a:rPr/>
-              <a:t>“When we refer to data, we mean information about people, things and systems. … Data about people can include personal data, such as basic contact details, records generated through interaction with services or the web, or information about their physical characteristics (biometrics) - and it can also extend to population-level data, such as demographics. Data can also be about systems and infrastructure, such as administrative records about businesses and public services. Data is increasingly used to describe location, such as geospatial reference details, and the environment we live in, such as data about biodiversity or the weather. It can also refer to the information generated by the burgeoning web of sensors that make up the Internet of Things.”</a:t>
-            </a:r>
-          </a:p>
-          <a:p>
-            <a:pPr lvl="0" indent="0">
-              <a:buNone/>
-            </a:pPr>
-            <a:r>
-              <a:rPr>
-                <a:latin typeface="Courier"/>
-              </a:rPr>
-              <a:t>                                                 - UK National Data Strategy</a:t>
-            </a:r>
-          </a:p>
-        </p:txBody>
-      </p:sp>
-    </p:spTree>
-  </p:cSld>
-</p:sld>
-</file>
-
-<file path=ppt/slides/slide5.xml><?xml version="1.0" encoding="utf-8"?>
 <p:sld xmlns:a="http://schemas.openxmlformats.org/drawingml/2006/main" xmlns:r="http://schemas.openxmlformats.org/officeDocument/2006/relationships" xmlns:p="http://schemas.openxmlformats.org/presentationml/2006/main">
   <p:cSld>
     <p:spTree>
@@ -5557,7 +5402,7 @@
 </p:sld>
 </file>
 
-<file path=ppt/slides/slide6.xml><?xml version="1.0" encoding="utf-8"?>
+<file path=ppt/slides/slide5.xml><?xml version="1.0" encoding="utf-8"?>
 <p:sld xmlns:a="http://schemas.openxmlformats.org/drawingml/2006/main" xmlns:r="http://schemas.openxmlformats.org/officeDocument/2006/relationships" xmlns:p="http://schemas.openxmlformats.org/presentationml/2006/main">
   <p:cSld>
     <p:spTree>
@@ -5634,6 +5479,112 @@
 </p:sld>
 </file>
 
+<file path=ppt/slides/slide6.xml><?xml version="1.0" encoding="utf-8"?>
+<p:sld xmlns:a="http://schemas.openxmlformats.org/drawingml/2006/main" xmlns:r="http://schemas.openxmlformats.org/officeDocument/2006/relationships" xmlns:p="http://schemas.openxmlformats.org/presentationml/2006/main">
+  <p:cSld>
+    <p:spTree>
+      <p:nvGrpSpPr>
+        <p:cNvPr id="1" name=""/>
+        <p:cNvGrpSpPr/>
+        <p:nvPr/>
+      </p:nvGrpSpPr>
+      <p:grpSpPr>
+        <a:xfrm>
+          <a:off x="0" y="0"/>
+          <a:ext cx="0" cy="0"/>
+          <a:chOff x="0" y="0"/>
+          <a:chExt cx="0" cy="0"/>
+        </a:xfrm>
+      </p:grpSpPr>
+      <p:sp>
+        <p:nvSpPr>
+          <p:cNvPr id="3" name="Content Placeholder 2"/>
+          <p:cNvSpPr>
+            <a:spLocks noGrp="1"/>
+          </p:cNvSpPr>
+          <p:nvPr>
+            <p:ph idx="1" sz="half"/>
+          </p:nvPr>
+        </p:nvSpPr>
+        <p:spPr/>
+        <p:txBody>
+          <a:bodyPr/>
+          <a:lstStyle/>
+          <a:p>
+            <a:pPr lvl="0" indent="0" marL="0">
+              <a:spcBef>
+                <a:spcPts val="3000"/>
+              </a:spcBef>
+              <a:buNone/>
+            </a:pPr>
+            <a:r>
+              <a:rPr b="1"/>
+              <a:t>Public intent data</a:t>
+            </a:r>
+          </a:p>
+          <a:p>
+            <a:pPr lvl="0"/>
+            <a:r>
+              <a:rPr/>
+              <a:t>Public intent data is data collected for public purposes.</a:t>
+            </a:r>
+          </a:p>
+          <a:p>
+            <a:pPr lvl="0"/>
+            <a:r>
+              <a:rPr/>
+              <a:t>Public intent data is a foundation of public policies and can play a transformative role in the public sector.</a:t>
+            </a:r>
+          </a:p>
+        </p:txBody>
+      </p:sp>
+      <p:sp>
+        <p:nvSpPr>
+          <p:cNvPr id="4" name="Content Placeholder 3"/>
+          <p:cNvSpPr>
+            <a:spLocks noGrp="1"/>
+          </p:cNvSpPr>
+          <p:nvPr>
+            <p:ph idx="2" sz="half"/>
+          </p:nvPr>
+        </p:nvSpPr>
+        <p:spPr/>
+        <p:txBody>
+          <a:bodyPr/>
+          <a:lstStyle/>
+          <a:p>
+            <a:pPr lvl="0" indent="0" marL="0">
+              <a:spcBef>
+                <a:spcPts val="3000"/>
+              </a:spcBef>
+              <a:buNone/>
+            </a:pPr>
+            <a:r>
+              <a:rPr b="1"/>
+              <a:t>Private intent data</a:t>
+            </a:r>
+          </a:p>
+          <a:p>
+            <a:pPr lvl="0"/>
+            <a:r>
+              <a:rPr/>
+              <a:t>Private intent data is data collected by the private sector as part of routine business processes.</a:t>
+            </a:r>
+          </a:p>
+          <a:p>
+            <a:pPr lvl="0"/>
+            <a:r>
+              <a:rPr/>
+              <a:t>Private intent data can drive innovation, lower transaction costs, and improve productivity, competitiveness, and economic growth.</a:t>
+            </a:r>
+          </a:p>
+        </p:txBody>
+      </p:sp>
+    </p:spTree>
+  </p:cSld>
+</p:sld>
+</file>
+
 <file path=ppt/slides/slide7.xml><?xml version="1.0" encoding="utf-8"?>
 <p:sld xmlns:a="http://schemas.openxmlformats.org/drawingml/2006/main" xmlns:r="http://schemas.openxmlformats.org/officeDocument/2006/relationships" xmlns:p="http://schemas.openxmlformats.org/presentationml/2006/main">
   <p:cSld>
@@ -5653,84 +5604,83 @@
       </p:grpSpPr>
       <p:sp>
         <p:nvSpPr>
+          <p:cNvPr id="2" name="Title 1"/>
+          <p:cNvSpPr>
+            <a:spLocks noGrp="1"/>
+          </p:cNvSpPr>
+          <p:nvPr>
+            <p:ph type="title"/>
+          </p:nvPr>
+        </p:nvSpPr>
+        <p:spPr/>
+        <p:txBody>
+          <a:bodyPr/>
+          <a:lstStyle/>
+          <a:p>
+            <a:pPr lvl="0" indent="0" marL="0">
+              <a:buNone/>
+            </a:pPr>
+            <a:r>
+              <a:rPr/>
+              <a:t>Types of public intent data</a:t>
+            </a:r>
+          </a:p>
+        </p:txBody>
+      </p:sp>
+      <p:sp>
+        <p:nvSpPr>
           <p:cNvPr id="3" name="Content Placeholder 2"/>
           <p:cNvSpPr>
             <a:spLocks noGrp="1"/>
           </p:cNvSpPr>
           <p:nvPr>
-            <p:ph idx="1" sz="half"/>
-          </p:nvPr>
-        </p:nvSpPr>
-        <p:spPr/>
-        <p:txBody>
-          <a:bodyPr/>
-          <a:lstStyle/>
-          <a:p>
-            <a:pPr lvl="0" indent="0" marL="0">
-              <a:spcBef>
-                <a:spcPts val="3000"/>
-              </a:spcBef>
-              <a:buNone/>
-            </a:pPr>
-            <a:r>
-              <a:rPr b="1"/>
-              <a:t>Public intent data</a:t>
-            </a:r>
-          </a:p>
-          <a:p>
-            <a:pPr lvl="0"/>
-            <a:r>
-              <a:rPr/>
-              <a:t>Public intent data is data collected for public purposes.</a:t>
-            </a:r>
-          </a:p>
-          <a:p>
-            <a:pPr lvl="0"/>
-            <a:r>
-              <a:rPr/>
-              <a:t>Public intent data is a foundation of public policies and can play a transformative role in the public sector.</a:t>
-            </a:r>
-          </a:p>
-        </p:txBody>
-      </p:sp>
-      <p:sp>
-        <p:nvSpPr>
-          <p:cNvPr id="4" name="Content Placeholder 3"/>
-          <p:cNvSpPr>
-            <a:spLocks noGrp="1"/>
-          </p:cNvSpPr>
-          <p:nvPr>
-            <p:ph idx="2" sz="half"/>
-          </p:nvPr>
-        </p:nvSpPr>
-        <p:spPr/>
-        <p:txBody>
-          <a:bodyPr/>
-          <a:lstStyle/>
-          <a:p>
-            <a:pPr lvl="0" indent="0" marL="0">
-              <a:spcBef>
-                <a:spcPts val="3000"/>
-              </a:spcBef>
-              <a:buNone/>
-            </a:pPr>
-            <a:r>
-              <a:rPr b="1"/>
-              <a:t>Private intent data</a:t>
-            </a:r>
-          </a:p>
-          <a:p>
-            <a:pPr lvl="0"/>
-            <a:r>
-              <a:rPr/>
-              <a:t>Private intent data is data collected by the private sector as part of routine business processes.</a:t>
-            </a:r>
-          </a:p>
-          <a:p>
-            <a:pPr lvl="0"/>
-            <a:r>
-              <a:rPr/>
-              <a:t>Private intent data can drive innovation, lower transaction costs, and improve productivity, competitiveness, and economic growth.</a:t>
+            <p:ph idx="1"/>
+          </p:nvPr>
+        </p:nvSpPr>
+        <p:spPr/>
+        <p:txBody>
+          <a:bodyPr/>
+          <a:lstStyle/>
+          <a:p>
+            <a:pPr lvl="0"/>
+            <a:r>
+              <a:rPr/>
+              <a:t>Administrative data</a:t>
+            </a:r>
+          </a:p>
+          <a:p>
+            <a:pPr lvl="0"/>
+            <a:r>
+              <a:rPr/>
+              <a:t>Census data</a:t>
+            </a:r>
+          </a:p>
+          <a:p>
+            <a:pPr lvl="0"/>
+            <a:r>
+              <a:rPr/>
+              <a:t>Sample surveys</a:t>
+            </a:r>
+          </a:p>
+          <a:p>
+            <a:pPr lvl="0"/>
+            <a:r>
+              <a:rPr/>
+              <a:t>Citizen-generated data</a:t>
+            </a:r>
+          </a:p>
+          <a:p>
+            <a:pPr lvl="0"/>
+            <a:r>
+              <a:rPr/>
+              <a:t>Machine-generated data</a:t>
+            </a:r>
+          </a:p>
+          <a:p>
+            <a:pPr lvl="0"/>
+            <a:r>
+              <a:rPr/>
+              <a:t>Geospatial data</a:t>
             </a:r>
           </a:p>
         </p:txBody>
@@ -5741,111 +5691,6 @@
 </file>
 
 <file path=ppt/slides/slide8.xml><?xml version="1.0" encoding="utf-8"?>
-<p:sld xmlns:a="http://schemas.openxmlformats.org/drawingml/2006/main" xmlns:r="http://schemas.openxmlformats.org/officeDocument/2006/relationships" xmlns:p="http://schemas.openxmlformats.org/presentationml/2006/main">
-  <p:cSld>
-    <p:spTree>
-      <p:nvGrpSpPr>
-        <p:cNvPr id="1" name=""/>
-        <p:cNvGrpSpPr/>
-        <p:nvPr/>
-      </p:nvGrpSpPr>
-      <p:grpSpPr>
-        <a:xfrm>
-          <a:off x="0" y="0"/>
-          <a:ext cx="0" cy="0"/>
-          <a:chOff x="0" y="0"/>
-          <a:chExt cx="0" cy="0"/>
-        </a:xfrm>
-      </p:grpSpPr>
-      <p:sp>
-        <p:nvSpPr>
-          <p:cNvPr id="2" name="Title 1"/>
-          <p:cNvSpPr>
-            <a:spLocks noGrp="1"/>
-          </p:cNvSpPr>
-          <p:nvPr>
-            <p:ph type="title"/>
-          </p:nvPr>
-        </p:nvSpPr>
-        <p:spPr/>
-        <p:txBody>
-          <a:bodyPr/>
-          <a:lstStyle/>
-          <a:p>
-            <a:pPr lvl="0" indent="0" marL="0">
-              <a:buNone/>
-            </a:pPr>
-            <a:r>
-              <a:rPr/>
-              <a:t>Types of public intent data</a:t>
-            </a:r>
-          </a:p>
-        </p:txBody>
-      </p:sp>
-      <p:sp>
-        <p:nvSpPr>
-          <p:cNvPr id="3" name="Content Placeholder 2"/>
-          <p:cNvSpPr>
-            <a:spLocks noGrp="1"/>
-          </p:cNvSpPr>
-          <p:nvPr>
-            <p:ph idx="1"/>
-          </p:nvPr>
-        </p:nvSpPr>
-        <p:spPr/>
-        <p:txBody>
-          <a:bodyPr/>
-          <a:lstStyle/>
-          <a:p>
-            <a:pPr lvl="0"/>
-            <a:r>
-              <a:rPr/>
-              <a:t>Administrative data</a:t>
-            </a:r>
-          </a:p>
-          <a:p>
-            <a:pPr lvl="0"/>
-            <a:r>
-              <a:rPr/>
-              <a:t>Census data</a:t>
-            </a:r>
-          </a:p>
-          <a:p>
-            <a:pPr lvl="0"/>
-            <a:r>
-              <a:rPr/>
-              <a:t>Sample surveys</a:t>
-            </a:r>
-          </a:p>
-          <a:p>
-            <a:pPr lvl="0"/>
-            <a:r>
-              <a:rPr/>
-              <a:t>Citizen-generated data</a:t>
-            </a:r>
-          </a:p>
-          <a:p>
-            <a:pPr lvl="0"/>
-            <a:r>
-              <a:rPr/>
-              <a:t>Machine-generated data</a:t>
-            </a:r>
-          </a:p>
-          <a:p>
-            <a:pPr lvl="0"/>
-            <a:r>
-              <a:rPr/>
-              <a:t>Geospatial data</a:t>
-            </a:r>
-          </a:p>
-        </p:txBody>
-      </p:sp>
-    </p:spTree>
-  </p:cSld>
-</p:sld>
-</file>
-
-<file path=ppt/slides/slide9.xml><?xml version="1.0" encoding="utf-8"?>
 <p:sld xmlns:a="http://schemas.openxmlformats.org/drawingml/2006/main" xmlns:r="http://schemas.openxmlformats.org/officeDocument/2006/relationships" xmlns:p="http://schemas.openxmlformats.org/presentationml/2006/main">
   <p:cSld>
     <p:spTree>
@@ -5917,6 +5762,90 @@
           </a:ln>
         </p:spPr>
       </p:pic>
+    </p:spTree>
+  </p:cSld>
+</p:sld>
+</file>
+
+<file path=ppt/slides/slide9.xml><?xml version="1.0" encoding="utf-8"?>
+<p:sld xmlns:a="http://schemas.openxmlformats.org/drawingml/2006/main" xmlns:r="http://schemas.openxmlformats.org/officeDocument/2006/relationships" xmlns:p="http://schemas.openxmlformats.org/presentationml/2006/main">
+  <p:cSld>
+    <p:spTree>
+      <p:nvGrpSpPr>
+        <p:cNvPr id="1" name=""/>
+        <p:cNvGrpSpPr/>
+        <p:nvPr/>
+      </p:nvGrpSpPr>
+      <p:grpSpPr>
+        <a:xfrm>
+          <a:off x="0" y="0"/>
+          <a:ext cx="0" cy="0"/>
+          <a:chOff x="0" y="0"/>
+          <a:chExt cx="0" cy="0"/>
+        </a:xfrm>
+      </p:grpSpPr>
+      <p:sp>
+        <p:nvSpPr>
+          <p:cNvPr id="2" name="Title 1"/>
+          <p:cNvSpPr>
+            <a:spLocks noGrp="1"/>
+          </p:cNvSpPr>
+          <p:nvPr>
+            <p:ph type="title"/>
+          </p:nvPr>
+        </p:nvSpPr>
+        <p:spPr/>
+        <p:txBody>
+          <a:bodyPr/>
+          <a:lstStyle/>
+          <a:p>
+            <a:pPr lvl="0" indent="0" marL="0">
+              <a:buNone/>
+            </a:pPr>
+            <a:r>
+              <a:rPr/>
+              <a:t>Three pathways for public intent data to add value</a:t>
+            </a:r>
+          </a:p>
+        </p:txBody>
+      </p:sp>
+      <p:sp>
+        <p:nvSpPr>
+          <p:cNvPr id="3" name="Content Placeholder 2"/>
+          <p:cNvSpPr>
+            <a:spLocks noGrp="1"/>
+          </p:cNvSpPr>
+          <p:nvPr>
+            <p:ph idx="1"/>
+          </p:nvPr>
+        </p:nvSpPr>
+        <p:spPr/>
+        <p:txBody>
+          <a:bodyPr/>
+          <a:lstStyle/>
+          <a:p>
+            <a:pPr lvl="0"/>
+            <a:r>
+              <a:rPr/>
+              <a:t>Improving service delivery</a:t>
+            </a:r>
+          </a:p>
+          <a:p>
+            <a:pPr lvl="0"/>
+            <a:r>
+              <a:rPr/>
+              <a:t>Prioritising scarce resources</a:t>
+            </a:r>
+          </a:p>
+          <a:p>
+            <a:pPr lvl="0"/>
+            <a:r>
+              <a:rPr/>
+              <a:t>Holding government accountable and empowering individuals</a:t>
+            </a:r>
+          </a:p>
+        </p:txBody>
+      </p:sp>
     </p:spTree>
   </p:cSld>
 </p:sld>

</xml_diff>

<commit_message>
Deploying to gh-pages from @ tamanh-oxford/capacity-development@597303b34a413656965baf831bfc4e4e5f4b0867 🚀
</commit_message>
<xml_diff>
--- a/data-frameworks/01-global-landscape.pptx
+++ b/data-frameworks/01-global-landscape.pptx
@@ -6568,6 +6568,10 @@
             </a:r>
             <a:br/>
             <a:br/>
+            <a:r>
+              <a:rPr/>
+              <a:t>Ernest Guevarra</a:t>
+            </a:r>
           </a:p>
         </p:txBody>
       </p:sp>

</xml_diff>